<commit_message>
Relabel slide 7 takeaway; add what-this-shows captions on slides 8 and 14
</commit_message>
<xml_diff>
--- a/presentation/Math142_Presentation.pptx
+++ b/presentation/Math142_Presentation.pptx
@@ -1099,182 +1099,6 @@
             <a:fld id="{F7021451-1387-4CA6-816F-3879F97B5CBC}" type="slidenum">
               <a:rPr lang="en-US"/>
               <a:t>15</a:t>
-            </a:fld>
-            <a:endParaRPr lang="en-US"/>
-          </a:p>
-        </p:txBody>
-      </p:sp>
-    </p:spTree>
-    <p:extLst>
-      <p:ext uri="{BB962C8B-B14F-4D97-AF65-F5344CB8AC3E}">
-        <p14:creationId xmlns:p14="http://schemas.microsoft.com/office/powerpoint/2010/main" val="1024086991"/>
-      </p:ext>
-    </p:extLst>
-  </p:cSld>
-  <p:clrMapOvr>
-    <a:masterClrMapping/>
-  </p:clrMapOvr>
-</p:notes>
-</file>
-
-<file path=ppt/notesSlides/notesSlide16.xml><?xml version="1.0" encoding="utf-8"?>
-<p:notes xmlns:a="http://schemas.openxmlformats.org/drawingml/2006/main" xmlns:r="http://schemas.openxmlformats.org/officeDocument/2006/relationships" xmlns:p="http://schemas.openxmlformats.org/presentationml/2006/main">
-  <p:cSld>
-    <p:spTree>
-      <p:nvGrpSpPr>
-        <p:cNvPr id="1" name=""/>
-        <p:cNvGrpSpPr/>
-        <p:nvPr/>
-      </p:nvGrpSpPr>
-      <p:grpSpPr>
-        <a:xfrm>
-          <a:off x="0" y="0"/>
-          <a:ext cx="0" cy="0"/>
-          <a:chOff x="0" y="0"/>
-          <a:chExt cx="0" cy="0"/>
-        </a:xfrm>
-      </p:grpSpPr>
-      <p:sp>
-        <p:nvSpPr>
-          <p:cNvPr id="2" name="Slide Image Placeholder 1"/>
-          <p:cNvSpPr>
-            <a:spLocks noGrp="1" noRot="1" noChangeAspect="1"/>
-          </p:cNvSpPr>
-          <p:nvPr>
-            <p:ph type="sldImg"/>
-          </p:nvPr>
-        </p:nvSpPr>
-        <p:spPr/>
-      </p:sp>
-      <p:sp>
-        <p:nvSpPr>
-          <p:cNvPr id="3" name="Notes Placeholder 2"/>
-          <p:cNvSpPr>
-            <a:spLocks noGrp="1"/>
-          </p:cNvSpPr>
-          <p:nvPr>
-            <p:ph type="body" idx="1"/>
-          </p:nvPr>
-        </p:nvSpPr>
-        <p:spPr/>
-        <p:txBody>
-          <a:bodyPr/>
-          <a:lstStyle/>
-          <a:p>
-            <a:r>
-              <a:rPr lang="en-US" dirty="0"/>
-              <a:t>If asked why optimal knobs differ across riders — point to the flat basin; they’re all near the same finishing time.</a:t>
-            </a:r>
-            <a:endParaRPr lang="en-US" dirty="0"/>
-          </a:p>
-        </p:txBody>
-      </p:sp>
-      <p:sp>
-        <p:nvSpPr>
-          <p:cNvPr id="4" name="Slide Number Placeholder 3"/>
-          <p:cNvSpPr>
-            <a:spLocks noGrp="1"/>
-          </p:cNvSpPr>
-          <p:nvPr>
-            <p:ph type="sldNum" sz="quarter" idx="10"/>
-          </p:nvPr>
-        </p:nvSpPr>
-        <p:spPr/>
-        <p:txBody>
-          <a:bodyPr/>
-          <a:lstStyle/>
-          <a:p>
-            <a:fld id="{F7021451-1387-4CA6-816F-3879F97B5CBC}" type="slidenum">
-              <a:rPr lang="en-US"/>
-              <a:t>16</a:t>
-            </a:fld>
-            <a:endParaRPr lang="en-US"/>
-          </a:p>
-        </p:txBody>
-      </p:sp>
-    </p:spTree>
-    <p:extLst>
-      <p:ext uri="{BB962C8B-B14F-4D97-AF65-F5344CB8AC3E}">
-        <p14:creationId xmlns:p14="http://schemas.microsoft.com/office/powerpoint/2010/main" val="1024086991"/>
-      </p:ext>
-    </p:extLst>
-  </p:cSld>
-  <p:clrMapOvr>
-    <a:masterClrMapping/>
-  </p:clrMapOvr>
-</p:notes>
-</file>
-
-<file path=ppt/notesSlides/notesSlide17.xml><?xml version="1.0" encoding="utf-8"?>
-<p:notes xmlns:a="http://schemas.openxmlformats.org/drawingml/2006/main" xmlns:r="http://schemas.openxmlformats.org/officeDocument/2006/relationships" xmlns:p="http://schemas.openxmlformats.org/presentationml/2006/main">
-  <p:cSld>
-    <p:spTree>
-      <p:nvGrpSpPr>
-        <p:cNvPr id="1" name=""/>
-        <p:cNvGrpSpPr/>
-        <p:nvPr/>
-      </p:nvGrpSpPr>
-      <p:grpSpPr>
-        <a:xfrm>
-          <a:off x="0" y="0"/>
-          <a:ext cx="0" cy="0"/>
-          <a:chOff x="0" y="0"/>
-          <a:chExt cx="0" cy="0"/>
-        </a:xfrm>
-      </p:grpSpPr>
-      <p:sp>
-        <p:nvSpPr>
-          <p:cNvPr id="2" name="Slide Image Placeholder 1"/>
-          <p:cNvSpPr>
-            <a:spLocks noGrp="1" noRot="1" noChangeAspect="1"/>
-          </p:cNvSpPr>
-          <p:nvPr>
-            <p:ph type="sldImg"/>
-          </p:nvPr>
-        </p:nvSpPr>
-        <p:spPr/>
-      </p:sp>
-      <p:sp>
-        <p:nvSpPr>
-          <p:cNvPr id="3" name="Notes Placeholder 2"/>
-          <p:cNvSpPr>
-            <a:spLocks noGrp="1"/>
-          </p:cNvSpPr>
-          <p:nvPr>
-            <p:ph type="body" idx="1"/>
-          </p:nvPr>
-        </p:nvSpPr>
-        <p:spPr/>
-        <p:txBody>
-          <a:bodyPr/>
-          <a:lstStyle/>
-          <a:p>
-            <a:r>
-              <a:rPr lang="en-US" dirty="0"/>
-              <a:t>These back up the claim that the strategy generalizes — only the magnitudes change across riders.</a:t>
-            </a:r>
-            <a:endParaRPr lang="en-US" dirty="0"/>
-          </a:p>
-        </p:txBody>
-      </p:sp>
-      <p:sp>
-        <p:nvSpPr>
-          <p:cNvPr id="4" name="Slide Number Placeholder 3"/>
-          <p:cNvSpPr>
-            <a:spLocks noGrp="1"/>
-          </p:cNvSpPr>
-          <p:nvPr>
-            <p:ph type="sldNum" sz="quarter" idx="10"/>
-          </p:nvPr>
-        </p:nvSpPr>
-        <p:spPr/>
-        <p:txBody>
-          <a:bodyPr/>
-          <a:lstStyle/>
-          <a:p>
-            <a:fld id="{F7021451-1387-4CA6-816F-3879F97B5CBC}" type="slidenum">
-              <a:rPr lang="en-US"/>
-              <a:t>17</a:t>
             </a:fld>
             <a:endParaRPr lang="en-US"/>
           </a:p>
@@ -5785,14 +5609,48 @@
         </p:blipFill>
         <p:spPr>
           <a:xfrm>
-            <a:off x="548640" y="4251960"/>
-            <a:ext cx="11064240" cy="1965960"/>
+            <a:off x="1203807" y="4160520"/>
+            <a:ext cx="9784080" cy="1738493"/>
           </a:xfrm>
           <a:prstGeom prst="rect">
             <a:avLst/>
           </a:prstGeom>
         </p:spPr>
       </p:pic>
+      <p:sp>
+        <p:nvSpPr>
+          <p:cNvPr id="21" name="TextBox 20"/>
+          <p:cNvSpPr txBox="1"/>
+          <p:nvPr/>
+        </p:nvSpPr>
+        <p:spPr>
+          <a:xfrm>
+            <a:off x="1203807" y="5944733"/>
+            <a:ext cx="9784080" cy="320040"/>
+          </a:xfrm>
+          <a:prstGeom prst="rect">
+            <a:avLst/>
+          </a:prstGeom>
+          <a:noFill/>
+        </p:spPr>
+        <p:txBody>
+          <a:bodyPr wrap="square">
+            <a:noAutofit/>
+          </a:bodyPr>
+          <a:lstStyle/>
+          <a:p>
+            <a:r>
+              <a:rPr sz="1050">
+                <a:solidFill>
+                  <a:srgbClr val="6B6258"/>
+                </a:solidFill>
+                <a:latin typeface="Inter"/>
+              </a:rPr>
+              <a:t>What this shows: riders draft behind the leader and rotate the front; the team's clock is the 4th rider.</a:t>
+            </a:r>
+          </a:p>
+        </p:txBody>
+      </p:sp>
     </p:spTree>
   </p:cSld>
   <p:clrMapOvr>
@@ -6362,1625 +6220,6 @@
 </file>
 
 <file path=ppt/slides/slide16.xml><?xml version="1.0" encoding="utf-8"?>
-<p:sld xmlns:a="http://schemas.openxmlformats.org/drawingml/2006/main" xmlns:r="http://schemas.openxmlformats.org/officeDocument/2006/relationships" xmlns:p="http://schemas.openxmlformats.org/presentationml/2006/main">
-  <p:cSld name="Slide 16">
-    <p:spTree>
-      <p:nvGrpSpPr>
-        <p:cNvPr id="1" name=""/>
-        <p:cNvGrpSpPr/>
-        <p:nvPr/>
-      </p:nvGrpSpPr>
-      <p:grpSpPr>
-        <a:xfrm>
-          <a:off x="0" y="0"/>
-          <a:ext cx="0" cy="0"/>
-          <a:chOff x="0" y="0"/>
-          <a:chExt cx="0" cy="0"/>
-        </a:xfrm>
-      </p:grpSpPr>
-      <p:sp>
-        <p:nvSpPr>
-          <p:cNvPr id="2" name="Text 0"/>
-          <p:cNvSpPr/>
-          <p:nvPr/>
-        </p:nvSpPr>
-        <p:spPr>
-          <a:xfrm>
-            <a:off x="548640" y="338328"/>
-            <a:ext cx="365760" cy="256032"/>
-          </a:xfrm>
-          <a:prstGeom prst="rect">
-            <a:avLst/>
-          </a:prstGeom>
-          <a:solidFill>
-            <a:srgbClr val="1A1714"/>
-          </a:solidFill>
-          <a:ln w="25400">
-            <a:solidFill>
-              <a:srgbClr val="1A1714"/>
-            </a:solidFill>
-          </a:ln>
-        </p:spPr>
-        <p:txBody>
-          <a:bodyPr wrap="none" rtlCol="0" anchor="ctr" lIns="0" rIns="0" tIns="0" bIns="0"/>
-          <a:lstStyle/>
-          <a:p>
-            <a:pPr algn="ctr" indent="0" marL="0">
-              <a:buNone/>
-            </a:pPr>
-            <a:r>
-              <a:rPr lang="en-US" sz="1100" dirty="0">
-                <a:solidFill>
-                  <a:srgbClr val="F0EAE0"/>
-                </a:solidFill>
-                <a:latin typeface="JetBrains Mono" pitchFamily="34" charset="0"/>
-                <a:ea typeface="JetBrains Mono" pitchFamily="34" charset="-122"/>
-                <a:cs typeface="JetBrains Mono" pitchFamily="34" charset="-120"/>
-              </a:rPr>
-              <a:t>B1</a:t>
-            </a:r>
-            <a:endParaRPr lang="en-US" sz="1300" dirty="0"/>
-          </a:p>
-        </p:txBody>
-      </p:sp>
-      <p:sp>
-        <p:nvSpPr>
-          <p:cNvPr id="3" name="Text 1"/>
-          <p:cNvSpPr/>
-          <p:nvPr/>
-        </p:nvSpPr>
-        <p:spPr>
-          <a:xfrm>
-            <a:off x="977494" y="368503"/>
-            <a:ext cx="5715000" cy="202997"/>
-          </a:xfrm>
-          <a:prstGeom prst="rect">
-            <a:avLst/>
-          </a:prstGeom>
-          <a:noFill/>
-          <a:ln/>
-        </p:spPr>
-        <p:txBody>
-          <a:bodyPr wrap="square" rtlCol="0" anchor="ctr"/>
-          <a:lstStyle/>
-          <a:p>
-            <a:pPr indent="0" marL="0">
-              <a:buNone/>
-            </a:pPr>
-            <a:r>
-              <a:rPr lang="en-US" sz="1000" b="1" spc="300" kern="0" dirty="0">
-                <a:solidFill>
-                  <a:srgbClr val="B5392A"/>
-                </a:solidFill>
-                <a:latin typeface="Inter" pitchFamily="34" charset="0"/>
-                <a:ea typeface="Inter" pitchFamily="34" charset="-122"/>
-                <a:cs typeface="Inter" pitchFamily="34" charset="-120"/>
-              </a:rPr>
-              <a:t>BACKUP</a:t>
-            </a:r>
-            <a:endParaRPr lang="en-US" sz="1000" dirty="0"/>
-          </a:p>
-        </p:txBody>
-      </p:sp>
-      <p:sp>
-        <p:nvSpPr>
-          <p:cNvPr id="4" name="Text 2"/>
-          <p:cNvSpPr/>
-          <p:nvPr/>
-        </p:nvSpPr>
-        <p:spPr>
-          <a:xfrm>
-            <a:off x="584302" y="609905"/>
-            <a:ext cx="10159898" cy="495605"/>
-          </a:xfrm>
-          <a:prstGeom prst="rect">
-            <a:avLst/>
-          </a:prstGeom>
-          <a:noFill/>
-          <a:ln/>
-        </p:spPr>
-        <p:txBody>
-          <a:bodyPr wrap="square" rtlCol="0" anchor="t"/>
-          <a:lstStyle/>
-          <a:p>
-            <a:pPr indent="0" marL="0">
-              <a:buNone/>
-            </a:pPr>
-            <a:r>
-              <a:rPr lang="en-US" sz="3100" b="1" dirty="0">
-                <a:solidFill>
-                  <a:srgbClr val="1A1714"/>
-                </a:solidFill>
-                <a:latin typeface="Playfair Display" pitchFamily="34" charset="0"/>
-                <a:ea typeface="Playfair Display" pitchFamily="34" charset="-122"/>
-                <a:cs typeface="Playfair Display" pitchFamily="34" charset="-120"/>
-              </a:rPr>
-              <a:t>Heatmap Detail / Knob Trade-off</a:t>
-            </a:r>
-            <a:endParaRPr lang="en-US" sz="3100" dirty="0"/>
-          </a:p>
-        </p:txBody>
-      </p:sp>
-      <p:sp>
-        <p:nvSpPr>
-          <p:cNvPr id="5" name="Shape 3"/>
-          <p:cNvSpPr/>
-          <p:nvPr/>
-        </p:nvSpPr>
-        <p:spPr>
-          <a:xfrm>
-            <a:off x="584302" y="1155802"/>
-            <a:ext cx="952805" cy="32004"/>
-          </a:xfrm>
-          <a:prstGeom prst="rect">
-            <a:avLst/>
-          </a:prstGeom>
-          <a:solidFill>
-            <a:srgbClr val="B5392A"/>
-          </a:solidFill>
-          <a:ln/>
-        </p:spPr>
-        <p:txBody>
-          <a:bodyPr/>
-          <a:p/>
-        </p:txBody>
-      </p:sp>
-      <p:sp>
-        <p:nvSpPr>
-          <p:cNvPr id="6" name="Text 4"/>
-          <p:cNvSpPr/>
-          <p:nvPr/>
-        </p:nvSpPr>
-        <p:spPr>
-          <a:xfrm>
-            <a:off x="584302" y="1524305"/>
-            <a:ext cx="4419295" cy="2794406"/>
-          </a:xfrm>
-          <a:prstGeom prst="rect">
-            <a:avLst/>
-          </a:prstGeom>
-          <a:noFill/>
-          <a:ln/>
-        </p:spPr>
-        <p:txBody>
-          <a:bodyPr wrap="square" rtlCol="0" anchor="t"/>
-          <a:lstStyle/>
-          <a:p>
-            <a:pPr indent="0" marL="0">
-              <a:lnSpc>
-                <a:spcPct val="122000"/>
-              </a:lnSpc>
-              <a:spcAft>
-                <a:spcPts val="600"/>
-              </a:spcAft>
-              <a:buNone/>
-            </a:pPr>
-            <a:r>
-              <a:rPr lang="en-US" sz="1550" b="1" dirty="0">
-                <a:solidFill>
-                  <a:srgbClr val="B5392A"/>
-                </a:solidFill>
-                <a:latin typeface="Inter" pitchFamily="34" charset="0"/>
-                <a:ea typeface="Inter" pitchFamily="34" charset="-122"/>
-                <a:cs typeface="Inter" pitchFamily="34" charset="-120"/>
-              </a:rPr>
-              <a:t>■  </a:t>
-            </a:r>
-            <a:pPr indent="0" marL="0">
-              <a:lnSpc>
-                <a:spcPct val="122000"/>
-              </a:lnSpc>
-              <a:spcAft>
-                <a:spcPts val="600"/>
-              </a:spcAft>
-              <a:buNone/>
-            </a:pPr>
-            <a:r>
-              <a:rPr lang="en-US" sz="1550" dirty="0">
-                <a:solidFill>
-                  <a:srgbClr val="1A1714"/>
-                </a:solidFill>
-                <a:latin typeface="Inter" pitchFamily="34" charset="0"/>
-                <a:ea typeface="Inter" pitchFamily="34" charset="-122"/>
-                <a:cs typeface="Inter" pitchFamily="34" charset="-120"/>
-              </a:rPr>
-              <a:t>Flat basin → hill_factor and flat_boost substitute for each other</a:t>
-            </a:r>
-            <a:pPr indent="0" marL="0">
-              <a:lnSpc>
-                <a:spcPct val="122000"/>
-              </a:lnSpc>
-              <a:spcAft>
-                <a:spcPts val="600"/>
-              </a:spcAft>
-              <a:buNone/>
-            </a:pPr>
-            <a:endParaRPr lang="en-US" sz="1550" dirty="0"/>
-          </a:p>
-          <a:p>
-            <a:pPr indent="0" marL="0">
-              <a:lnSpc>
-                <a:spcPct val="122000"/>
-              </a:lnSpc>
-              <a:spcAft>
-                <a:spcPts val="600"/>
-              </a:spcAft>
-              <a:buNone/>
-            </a:pPr>
-            <a:r>
-              <a:rPr lang="en-US" sz="1550" b="1" dirty="0">
-                <a:solidFill>
-                  <a:srgbClr val="B5392A"/>
-                </a:solidFill>
-                <a:latin typeface="Inter" pitchFamily="34" charset="0"/>
-                <a:ea typeface="Inter" pitchFamily="34" charset="-122"/>
-                <a:cs typeface="Inter" pitchFamily="34" charset="-120"/>
-              </a:rPr>
-              <a:t>■  </a:t>
-            </a:r>
-            <a:pPr indent="0" marL="0">
-              <a:lnSpc>
-                <a:spcPct val="122000"/>
-              </a:lnSpc>
-              <a:spcAft>
-                <a:spcPts val="600"/>
-              </a:spcAft>
-              <a:buNone/>
-            </a:pPr>
-            <a:r>
-              <a:rPr lang="en-US" sz="1550" dirty="0">
-                <a:solidFill>
-                  <a:srgbClr val="1A1714"/>
-                </a:solidFill>
-                <a:latin typeface="Inter" pitchFamily="34" charset="0"/>
-                <a:ea typeface="Inter" pitchFamily="34" charset="-122"/>
-                <a:cs typeface="Inter" pitchFamily="34" charset="-120"/>
-              </a:rPr>
-              <a:t>Lower the flat_boost bound → optimizer raises hill_factor, same time</a:t>
-            </a:r>
-            <a:pPr indent="0" marL="0">
-              <a:lnSpc>
-                <a:spcPct val="122000"/>
-              </a:lnSpc>
-              <a:spcAft>
-                <a:spcPts val="600"/>
-              </a:spcAft>
-              <a:buNone/>
-            </a:pPr>
-            <a:endParaRPr lang="en-US" sz="1550" dirty="0"/>
-          </a:p>
-          <a:p>
-            <a:pPr indent="0" marL="0">
-              <a:lnSpc>
-                <a:spcPct val="122000"/>
-              </a:lnSpc>
-              <a:spcAft>
-                <a:spcPts val="600"/>
-              </a:spcAft>
-              <a:buNone/>
-            </a:pPr>
-            <a:r>
-              <a:rPr lang="en-US" sz="1550" b="1" dirty="0">
-                <a:solidFill>
-                  <a:srgbClr val="B5392A"/>
-                </a:solidFill>
-                <a:latin typeface="Inter" pitchFamily="34" charset="0"/>
-                <a:ea typeface="Inter" pitchFamily="34" charset="-122"/>
-                <a:cs typeface="Inter" pitchFamily="34" charset="-120"/>
-              </a:rPr>
-              <a:t>■  </a:t>
-            </a:r>
-            <a:pPr indent="0" marL="0">
-              <a:lnSpc>
-                <a:spcPct val="122000"/>
-              </a:lnSpc>
-              <a:spcAft>
-                <a:spcPts val="600"/>
-              </a:spcAft>
-              <a:buNone/>
-            </a:pPr>
-            <a:r>
-              <a:rPr lang="en-US" sz="1550" dirty="0">
-                <a:solidFill>
-                  <a:srgbClr val="1A1714"/>
-                </a:solidFill>
-                <a:latin typeface="Inter" pitchFamily="34" charset="0"/>
-                <a:ea typeface="Inter" pitchFamily="34" charset="-122"/>
-                <a:cs typeface="Inter" pitchFamily="34" charset="-120"/>
-              </a:rPr>
-              <a:t>Per-rider optimal knobs vary widely, finishing time does not</a:t>
-            </a:r>
-            <a:pPr indent="0" marL="0">
-              <a:lnSpc>
-                <a:spcPct val="122000"/>
-              </a:lnSpc>
-              <a:spcAft>
-                <a:spcPts val="600"/>
-              </a:spcAft>
-              <a:buNone/>
-            </a:pPr>
-            <a:endParaRPr lang="en-US" sz="1550" dirty="0"/>
-          </a:p>
-          <a:p>
-            <a:pPr indent="0" marL="0">
-              <a:lnSpc>
-                <a:spcPct val="122000"/>
-              </a:lnSpc>
-              <a:spcAft>
-                <a:spcPts val="600"/>
-              </a:spcAft>
-              <a:buNone/>
-            </a:pPr>
-            <a:r>
-              <a:rPr lang="en-US" sz="1550" b="1" dirty="0">
-                <a:solidFill>
-                  <a:srgbClr val="B5392A"/>
-                </a:solidFill>
-                <a:latin typeface="Inter" pitchFamily="34" charset="0"/>
-                <a:ea typeface="Inter" pitchFamily="34" charset="-122"/>
-                <a:cs typeface="Inter" pitchFamily="34" charset="-120"/>
-              </a:rPr>
-              <a:t>■  </a:t>
-            </a:r>
-            <a:pPr indent="0" marL="0">
-              <a:lnSpc>
-                <a:spcPct val="122000"/>
-              </a:lnSpc>
-              <a:spcAft>
-                <a:spcPts val="600"/>
-              </a:spcAft>
-              <a:buNone/>
-            </a:pPr>
-            <a:r>
-              <a:rPr lang="en-US" sz="1550" dirty="0">
-                <a:solidFill>
-                  <a:srgbClr val="1A1714"/>
-                </a:solidFill>
-                <a:latin typeface="Inter" pitchFamily="34" charset="0"/>
-                <a:ea typeface="Inter" pitchFamily="34" charset="-122"/>
-                <a:cs typeface="Inter" pitchFamily="34" charset="-120"/>
-              </a:rPr>
-              <a:t>Confirms strategy shape matters more than exact values</a:t>
-            </a:r>
-            <a:pPr indent="0" marL="0">
-              <a:lnSpc>
-                <a:spcPct val="122000"/>
-              </a:lnSpc>
-              <a:spcAft>
-                <a:spcPts val="600"/>
-              </a:spcAft>
-              <a:buNone/>
-            </a:pPr>
-            <a:endParaRPr lang="en-US" sz="1550" dirty="0"/>
-          </a:p>
-        </p:txBody>
-      </p:sp>
-      <p:sp>
-        <p:nvSpPr>
-          <p:cNvPr id="7" name="Shape 5"/>
-          <p:cNvSpPr/>
-          <p:nvPr/>
-        </p:nvSpPr>
-        <p:spPr>
-          <a:xfrm>
-            <a:off x="584302" y="2984602"/>
-            <a:ext cx="2152498" cy="584302"/>
-          </a:xfrm>
-          <a:prstGeom prst="rect">
-            <a:avLst/>
-          </a:prstGeom>
-          <a:solidFill>
-            <a:srgbClr val="FFFFFF"/>
-          </a:solidFill>
-          <a:ln w="25400">
-            <a:solidFill>
-              <a:srgbClr val="1A1714"/>
-            </a:solidFill>
-            <a:prstDash val="solid"/>
-          </a:ln>
-        </p:spPr>
-        <p:txBody>
-          <a:bodyPr/>
-          <a:p/>
-        </p:txBody>
-      </p:sp>
-      <p:sp>
-        <p:nvSpPr>
-          <p:cNvPr id="8" name="Text 6"/>
-          <p:cNvSpPr/>
-          <p:nvPr/>
-        </p:nvSpPr>
-        <p:spPr>
-          <a:xfrm>
-            <a:off x="685800" y="3060497"/>
-            <a:ext cx="1975104" cy="254203"/>
-          </a:xfrm>
-          <a:prstGeom prst="rect">
-            <a:avLst/>
-          </a:prstGeom>
-          <a:noFill/>
-          <a:ln/>
-        </p:spPr>
-        <p:txBody>
-          <a:bodyPr wrap="square" rtlCol="0" anchor="t"/>
-          <a:lstStyle/>
-          <a:p>
-            <a:pPr indent="0" marL="0">
-              <a:buNone/>
-            </a:pPr>
-            <a:r>
-              <a:rPr lang="en-US" sz="1600" b="1" dirty="0">
-                <a:solidFill>
-                  <a:srgbClr val="1A1714"/>
-                </a:solidFill>
-                <a:latin typeface="Playfair Display" pitchFamily="34" charset="0"/>
-                <a:ea typeface="Playfair Display" pitchFamily="34" charset="-122"/>
-                <a:cs typeface="Playfair Display" pitchFamily="34" charset="-120"/>
-              </a:rPr>
-              <a:t>1175 / 99 · 1548 / 20</a:t>
-            </a:r>
-            <a:endParaRPr lang="en-US" sz="1600" dirty="0"/>
-          </a:p>
-        </p:txBody>
-      </p:sp>
-      <p:sp>
-        <p:nvSpPr>
-          <p:cNvPr id="9" name="Text 7"/>
-          <p:cNvSpPr/>
-          <p:nvPr/>
-        </p:nvSpPr>
-        <p:spPr>
-          <a:xfrm>
-            <a:off x="685800" y="3327502"/>
-            <a:ext cx="1975104" cy="215798"/>
-          </a:xfrm>
-          <a:prstGeom prst="rect">
-            <a:avLst/>
-          </a:prstGeom>
-          <a:noFill/>
-          <a:ln/>
-        </p:spPr>
-        <p:txBody>
-          <a:bodyPr wrap="square" rtlCol="0" anchor="t"/>
-          <a:lstStyle/>
-          <a:p>
-            <a:pPr indent="0" marL="0">
-              <a:lnSpc>
-                <a:spcPct val="115000"/>
-              </a:lnSpc>
-              <a:buNone/>
-            </a:pPr>
-            <a:r>
-              <a:rPr lang="en-US" sz="950" dirty="0">
-                <a:solidFill>
-                  <a:srgbClr val="6B6258"/>
-                </a:solidFill>
-                <a:latin typeface="Inter" pitchFamily="34" charset="0"/>
-                <a:ea typeface="Inter" pitchFamily="34" charset="-122"/>
-                <a:cs typeface="Inter" pitchFamily="34" charset="-120"/>
-              </a:rPr>
-              <a:t>Tokyo opt knobs, male_tt · female_tt</a:t>
-            </a:r>
-            <a:endParaRPr lang="en-US" sz="950" dirty="0"/>
-          </a:p>
-        </p:txBody>
-      </p:sp>
-      <p:sp>
-        <p:nvSpPr>
-          <p:cNvPr id="10" name="Shape 8"/>
-          <p:cNvSpPr/>
-          <p:nvPr/>
-        </p:nvSpPr>
-        <p:spPr>
-          <a:xfrm>
-            <a:off x="2851099" y="2984602"/>
-            <a:ext cx="2152498" cy="584302"/>
-          </a:xfrm>
-          <a:prstGeom prst="rect">
-            <a:avLst/>
-          </a:prstGeom>
-          <a:solidFill>
-            <a:srgbClr val="FFFFFF"/>
-          </a:solidFill>
-          <a:ln w="25400">
-            <a:solidFill>
-              <a:srgbClr val="1A1714"/>
-            </a:solidFill>
-            <a:prstDash val="solid"/>
-          </a:ln>
-        </p:spPr>
-        <p:txBody>
-          <a:bodyPr/>
-          <a:p/>
-        </p:txBody>
-      </p:sp>
-      <p:sp>
-        <p:nvSpPr>
-          <p:cNvPr id="11" name="Text 9"/>
-          <p:cNvSpPr/>
-          <p:nvPr/>
-        </p:nvSpPr>
-        <p:spPr>
-          <a:xfrm>
-            <a:off x="2952598" y="3060497"/>
-            <a:ext cx="1975104" cy="254203"/>
-          </a:xfrm>
-          <a:prstGeom prst="rect">
-            <a:avLst/>
-          </a:prstGeom>
-          <a:noFill/>
-          <a:ln/>
-        </p:spPr>
-        <p:txBody>
-          <a:bodyPr wrap="square" rtlCol="0" anchor="t"/>
-          <a:lstStyle/>
-          <a:p>
-            <a:pPr indent="0" marL="0">
-              <a:buNone/>
-            </a:pPr>
-            <a:r>
-              <a:rPr lang="en-US" sz="1600" b="1" dirty="0">
-                <a:solidFill>
-                  <a:srgbClr val="1A1714"/>
-                </a:solidFill>
-                <a:latin typeface="Playfair Display" pitchFamily="34" charset="0"/>
-                <a:ea typeface="Playfair Display" pitchFamily="34" charset="-122"/>
-                <a:cs typeface="Playfair Display" pitchFamily="34" charset="-120"/>
-              </a:rPr>
-              <a:t>997 / 85 · 799 / 99</a:t>
-            </a:r>
-            <a:endParaRPr lang="en-US" sz="1600" dirty="0"/>
-          </a:p>
-        </p:txBody>
-      </p:sp>
-      <p:sp>
-        <p:nvSpPr>
-          <p:cNvPr id="12" name="Text 10"/>
-          <p:cNvSpPr/>
-          <p:nvPr/>
-        </p:nvSpPr>
-        <p:spPr>
-          <a:xfrm>
-            <a:off x="2952598" y="3327502"/>
-            <a:ext cx="1975104" cy="215798"/>
-          </a:xfrm>
-          <a:prstGeom prst="rect">
-            <a:avLst/>
-          </a:prstGeom>
-          <a:noFill/>
-          <a:ln/>
-        </p:spPr>
-        <p:txBody>
-          <a:bodyPr wrap="square" rtlCol="0" anchor="t"/>
-          <a:lstStyle/>
-          <a:p>
-            <a:pPr indent="0" marL="0">
-              <a:lnSpc>
-                <a:spcPct val="115000"/>
-              </a:lnSpc>
-              <a:buNone/>
-            </a:pPr>
-            <a:r>
-              <a:rPr lang="en-US" sz="950" dirty="0">
-                <a:solidFill>
-                  <a:srgbClr val="6B6258"/>
-                </a:solidFill>
-                <a:latin typeface="Inter" pitchFamily="34" charset="0"/>
-                <a:ea typeface="Inter" pitchFamily="34" charset="-122"/>
-                <a:cs typeface="Inter" pitchFamily="34" charset="-120"/>
-              </a:rPr>
-              <a:t>Tokyo opt knobs, male_clm · female_clm</a:t>
-            </a:r>
-            <a:endParaRPr lang="en-US" sz="950" dirty="0"/>
-          </a:p>
-        </p:txBody>
-      </p:sp>
-      <p:sp>
-        <p:nvSpPr>
-          <p:cNvPr id="13" name="Shape 11"/>
-          <p:cNvSpPr/>
-          <p:nvPr/>
-        </p:nvSpPr>
-        <p:spPr>
-          <a:xfrm>
-            <a:off x="584302" y="4280306"/>
-            <a:ext cx="4419295" cy="508406"/>
-          </a:xfrm>
-          <a:prstGeom prst="rect">
-            <a:avLst/>
-          </a:prstGeom>
-          <a:solidFill>
-            <a:srgbClr val="FFFFFF"/>
-          </a:solidFill>
-          <a:ln w="25400">
-            <a:solidFill>
-              <a:srgbClr val="1A1714"/>
-            </a:solidFill>
-            <a:prstDash val="solid"/>
-          </a:ln>
-        </p:spPr>
-        <p:txBody>
-          <a:bodyPr/>
-          <a:p/>
-        </p:txBody>
-      </p:sp>
-      <p:sp>
-        <p:nvSpPr>
-          <p:cNvPr id="14" name="Text 12"/>
-          <p:cNvSpPr/>
-          <p:nvPr/>
-        </p:nvSpPr>
-        <p:spPr>
-          <a:xfrm>
-            <a:off x="685800" y="4356202"/>
-            <a:ext cx="4241902" cy="215798"/>
-          </a:xfrm>
-          <a:prstGeom prst="rect">
-            <a:avLst/>
-          </a:prstGeom>
-          <a:noFill/>
-          <a:ln/>
-        </p:spPr>
-        <p:txBody>
-          <a:bodyPr wrap="square" rtlCol="0" anchor="ctr"/>
-          <a:lstStyle/>
-          <a:p>
-            <a:pPr indent="0" marL="0">
-              <a:buNone/>
-            </a:pPr>
-            <a:r>
-              <a:rPr lang="en-US" sz="1600" b="1" dirty="0">
-                <a:solidFill>
-                  <a:srgbClr val="1A1714"/>
-                </a:solidFill>
-                <a:latin typeface="Playfair Display" pitchFamily="34" charset="0"/>
-                <a:ea typeface="Playfair Display" pitchFamily="34" charset="-122"/>
-                <a:cs typeface="Playfair Display" pitchFamily="34" charset="-120"/>
-              </a:rPr>
-              <a:t>60 · 39 · 49 · 36</a:t>
-            </a:r>
-            <a:endParaRPr lang="en-US" sz="1600" dirty="0"/>
-          </a:p>
-        </p:txBody>
-      </p:sp>
-      <p:sp>
-        <p:nvSpPr>
-          <p:cNvPr id="15" name="Text 13"/>
-          <p:cNvSpPr/>
-          <p:nvPr/>
-        </p:nvSpPr>
-        <p:spPr>
-          <a:xfrm>
-            <a:off x="685800" y="4584802"/>
-            <a:ext cx="4241902" cy="165506"/>
-          </a:xfrm>
-          <a:prstGeom prst="rect">
-            <a:avLst/>
-          </a:prstGeom>
-          <a:noFill/>
-          <a:ln/>
-        </p:spPr>
-        <p:txBody>
-          <a:bodyPr wrap="square" rtlCol="0" anchor="ctr"/>
-          <a:lstStyle/>
-          <a:p>
-            <a:pPr indent="0" marL="0">
-              <a:buNone/>
-            </a:pPr>
-            <a:r>
-              <a:rPr lang="en-US" sz="950" dirty="0">
-                <a:solidFill>
-                  <a:srgbClr val="6B6258"/>
-                </a:solidFill>
-                <a:latin typeface="Inter" pitchFamily="34" charset="0"/>
-                <a:ea typeface="Inter" pitchFamily="34" charset="-122"/>
-                <a:cs typeface="Inter" pitchFamily="34" charset="-120"/>
-              </a:rPr>
-              <a:t>Flanders flat_boost (m_tt · f_tt · m_clm · f_clm)</a:t>
-            </a:r>
-            <a:endParaRPr lang="en-US" sz="950" dirty="0"/>
-          </a:p>
-        </p:txBody>
-      </p:sp>
-      <p:sp>
-        <p:nvSpPr>
-          <p:cNvPr id="16" name="Shape 14"/>
-          <p:cNvSpPr/>
-          <p:nvPr/>
-        </p:nvSpPr>
-        <p:spPr>
-          <a:xfrm>
-            <a:off x="5320894" y="1524305"/>
-            <a:ext cx="6286500" cy="3301898"/>
-          </a:xfrm>
-          <a:prstGeom prst="rect">
-            <a:avLst/>
-          </a:prstGeom>
-          <a:solidFill>
-            <a:srgbClr val="FFFFFF"/>
-          </a:solidFill>
-          <a:ln w="25400">
-            <a:solidFill>
-              <a:srgbClr val="1A1714"/>
-            </a:solidFill>
-            <a:prstDash val="solid"/>
-          </a:ln>
-        </p:spPr>
-        <p:txBody>
-          <a:bodyPr/>
-          <a:p/>
-        </p:txBody>
-      </p:sp>
-      <p:pic>
-        <p:nvPicPr>
-          <p:cNvPr id="17" name="Image 0" descr="mq569ll8-heatmap_tokyo.png">    </p:cNvPr>
-          <p:cNvPicPr>
-            <a:picLocks noChangeAspect="1"/>
-          </p:cNvPicPr>
-          <p:nvPr/>
-        </p:nvPicPr>
-        <p:blipFill>
-          <a:blip r:embed="rId1"/>
-          <a:stretch>
-            <a:fillRect/>
-          </a:stretch>
-        </p:blipFill>
-        <p:spPr>
-          <a:xfrm>
-            <a:off x="5435194" y="2039112"/>
-            <a:ext cx="6057900" cy="2271370"/>
-          </a:xfrm>
-          <a:prstGeom prst="rect">
-            <a:avLst/>
-          </a:prstGeom>
-        </p:spPr>
-      </p:pic>
-      <p:sp>
-        <p:nvSpPr>
-          <p:cNvPr id="18" name="Text 15"/>
-          <p:cNvSpPr/>
-          <p:nvPr/>
-        </p:nvSpPr>
-        <p:spPr>
-          <a:xfrm>
-            <a:off x="5320894" y="4876495"/>
-            <a:ext cx="4635094" cy="330098"/>
-          </a:xfrm>
-          <a:prstGeom prst="rect">
-            <a:avLst/>
-          </a:prstGeom>
-          <a:noFill/>
-          <a:ln/>
-        </p:spPr>
-        <p:txBody>
-          <a:bodyPr wrap="square" rtlCol="0" anchor="t"/>
-          <a:lstStyle/>
-          <a:p>
-            <a:pPr indent="0" marL="0">
-              <a:lnSpc>
-                <a:spcPct val="120000"/>
-              </a:lnSpc>
-              <a:buNone/>
-            </a:pPr>
-            <a:r>
-              <a:rPr lang="en-US" sz="1000" dirty="0">
-                <a:solidFill>
-                  <a:srgbClr val="6B6258"/>
-                </a:solidFill>
-                <a:latin typeface="Inter" pitchFamily="34" charset="0"/>
-                <a:ea typeface="Inter" pitchFamily="34" charset="-122"/>
-                <a:cs typeface="Inter" pitchFamily="34" charset="-120"/>
-              </a:rPr>
-              <a:t>Knob trade-off near the optimum, male TT specialist, Tokyo</a:t>
-            </a:r>
-            <a:endParaRPr lang="en-US" sz="1000" dirty="0"/>
-          </a:p>
-        </p:txBody>
-      </p:sp>
-      <p:sp>
-        <p:nvSpPr>
-          <p:cNvPr id="19" name="Text 16"/>
-          <p:cNvSpPr/>
-          <p:nvPr/>
-        </p:nvSpPr>
-        <p:spPr>
-          <a:xfrm>
-            <a:off x="10019995" y="4876495"/>
-            <a:ext cx="1587398" cy="165506"/>
-          </a:xfrm>
-          <a:prstGeom prst="rect">
-            <a:avLst/>
-          </a:prstGeom>
-          <a:solidFill>
-            <a:srgbClr val="1A1714"/>
-          </a:solidFill>
-          <a:ln/>
-        </p:spPr>
-        <p:txBody>
-          <a:bodyPr wrap="square" rtlCol="0" anchor="ctr"/>
-          <a:lstStyle/>
-          <a:p>
-            <a:pPr algn="ctr" indent="0" marL="0">
-              <a:buNone/>
-            </a:pPr>
-            <a:r>
-              <a:rPr lang="en-US" sz="800" dirty="0">
-                <a:solidFill>
-                  <a:srgbClr val="F0EAE0"/>
-                </a:solidFill>
-                <a:latin typeface="JetBrains Mono" pitchFamily="34" charset="0"/>
-                <a:ea typeface="JetBrains Mono" pitchFamily="34" charset="-122"/>
-                <a:cs typeface="JetBrains Mono" pitchFamily="34" charset="-120"/>
-              </a:rPr>
-              <a:t>heatmap_tokyo.png · zoom</a:t>
-            </a:r>
-            <a:endParaRPr lang="en-US" sz="800" dirty="0"/>
-          </a:p>
-        </p:txBody>
-      </p:sp>
-      <p:sp>
-        <p:nvSpPr>
-          <p:cNvPr id="20" name="Shape 17"/>
-          <p:cNvSpPr/>
-          <p:nvPr/>
-        </p:nvSpPr>
-        <p:spPr>
-          <a:xfrm>
-            <a:off x="584302" y="6349594"/>
-            <a:ext cx="11024006" cy="0"/>
-          </a:xfrm>
-          <a:prstGeom prst="line">
-            <a:avLst/>
-          </a:prstGeom>
-          <a:noFill/>
-          <a:ln w="25400">
-            <a:solidFill>
-              <a:srgbClr val="1A1714"/>
-            </a:solidFill>
-            <a:prstDash val="solid"/>
-          </a:ln>
-        </p:spPr>
-        <p:txBody>
-          <a:bodyPr/>
-          <a:p/>
-        </p:txBody>
-      </p:sp>
-      <p:sp>
-        <p:nvSpPr>
-          <p:cNvPr id="21" name="Text 18"/>
-          <p:cNvSpPr/>
-          <p:nvPr/>
-        </p:nvSpPr>
-        <p:spPr>
-          <a:xfrm>
-            <a:off x="584302" y="6400800"/>
-            <a:ext cx="5715000" cy="177394"/>
-          </a:xfrm>
-          <a:prstGeom prst="rect">
-            <a:avLst/>
-          </a:prstGeom>
-          <a:noFill/>
-          <a:ln/>
-        </p:spPr>
-        <p:txBody>
-          <a:bodyPr wrap="square" rtlCol="0" anchor="ctr"/>
-          <a:lstStyle/>
-          <a:p>
-            <a:pPr indent="0" marL="0">
-              <a:buNone/>
-            </a:pPr>
-            <a:r>
-              <a:rPr lang="en-US" sz="1050" dirty="0">
-                <a:solidFill>
-                  <a:srgbClr val="6B6258"/>
-                </a:solidFill>
-                <a:latin typeface="Inter" pitchFamily="34" charset="0"/>
-                <a:ea typeface="Inter" pitchFamily="34" charset="-122"/>
-                <a:cs typeface="Inter" pitchFamily="34" charset="-120"/>
-              </a:rPr>
-              <a:t>Power Profile of a Cyclist · Backup</a:t>
-            </a:r>
-            <a:endParaRPr lang="en-US" sz="1050" dirty="0"/>
-          </a:p>
-        </p:txBody>
-      </p:sp>
-      <p:sp>
-        <p:nvSpPr>
-          <p:cNvPr id="22" name="Text 19"/>
-          <p:cNvSpPr/>
-          <p:nvPr/>
-        </p:nvSpPr>
-        <p:spPr>
-          <a:xfrm>
-            <a:off x="9702698" y="6400800"/>
-            <a:ext cx="1904695" cy="177394"/>
-          </a:xfrm>
-          <a:prstGeom prst="rect">
-            <a:avLst/>
-          </a:prstGeom>
-          <a:noFill/>
-          <a:ln/>
-        </p:spPr>
-        <p:txBody>
-          <a:bodyPr wrap="square" rtlCol="0" anchor="ctr"/>
-          <a:lstStyle/>
-          <a:p>
-            <a:pPr algn="r" indent="0" marL="0">
-              <a:buNone/>
-            </a:pPr>
-            <a:r>
-              <a:rPr lang="en-US" sz="1050" b="1" spc="200" kern="0" dirty="0">
-                <a:solidFill>
-                  <a:srgbClr val="B5392A"/>
-                </a:solidFill>
-                <a:latin typeface="JetBrains Mono" pitchFamily="34" charset="0"/>
-                <a:ea typeface="JetBrains Mono" pitchFamily="34" charset="-122"/>
-                <a:cs typeface="JetBrains Mono" pitchFamily="34" charset="-120"/>
-              </a:rPr>
-              <a:t>B1</a:t>
-            </a:r>
-            <a:pPr algn="r" indent="0" marL="0">
-              <a:buNone/>
-            </a:pPr>
-            <a:endParaRPr lang="en-US" sz="1050" dirty="0"/>
-          </a:p>
-        </p:txBody>
-      </p:sp>
-    </p:spTree>
-  </p:cSld>
-  <p:clrMapOvr>
-    <a:masterClrMapping/>
-  </p:clrMapOvr>
-</p:sld>
-</file>
-
-<file path=ppt/slides/slide17.xml><?xml version="1.0" encoding="utf-8"?>
-<p:sld xmlns:a="http://schemas.openxmlformats.org/drawingml/2006/main" xmlns:r="http://schemas.openxmlformats.org/officeDocument/2006/relationships" xmlns:p="http://schemas.openxmlformats.org/presentationml/2006/main">
-  <p:cSld name="Slide 17">
-    <p:spTree>
-      <p:nvGrpSpPr>
-        <p:cNvPr id="1" name=""/>
-        <p:cNvGrpSpPr/>
-        <p:nvPr/>
-      </p:nvGrpSpPr>
-      <p:grpSpPr>
-        <a:xfrm>
-          <a:off x="0" y="0"/>
-          <a:ext cx="0" cy="0"/>
-          <a:chOff x="0" y="0"/>
-          <a:chExt cx="0" cy="0"/>
-        </a:xfrm>
-      </p:grpSpPr>
-      <p:sp>
-        <p:nvSpPr>
-          <p:cNvPr id="2" name="Text 0"/>
-          <p:cNvSpPr/>
-          <p:nvPr/>
-        </p:nvSpPr>
-        <p:spPr>
-          <a:xfrm>
-            <a:off x="548640" y="338328"/>
-            <a:ext cx="365760" cy="256032"/>
-          </a:xfrm>
-          <a:prstGeom prst="rect">
-            <a:avLst/>
-          </a:prstGeom>
-          <a:solidFill>
-            <a:srgbClr val="1A1714"/>
-          </a:solidFill>
-          <a:ln w="25400">
-            <a:solidFill>
-              <a:srgbClr val="1A1714"/>
-            </a:solidFill>
-          </a:ln>
-        </p:spPr>
-        <p:txBody>
-          <a:bodyPr wrap="none" rtlCol="0" anchor="ctr" lIns="0" rIns="0" tIns="0" bIns="0"/>
-          <a:lstStyle/>
-          <a:p>
-            <a:pPr algn="ctr" indent="0" marL="0">
-              <a:buNone/>
-            </a:pPr>
-            <a:r>
-              <a:rPr lang="en-US" sz="1100" dirty="0">
-                <a:solidFill>
-                  <a:srgbClr val="F0EAE0"/>
-                </a:solidFill>
-                <a:latin typeface="JetBrains Mono" pitchFamily="34" charset="0"/>
-                <a:ea typeface="JetBrains Mono" pitchFamily="34" charset="-122"/>
-                <a:cs typeface="JetBrains Mono" pitchFamily="34" charset="-120"/>
-              </a:rPr>
-              <a:t>B2</a:t>
-            </a:r>
-            <a:endParaRPr lang="en-US" sz="1300" dirty="0"/>
-          </a:p>
-        </p:txBody>
-      </p:sp>
-      <p:sp>
-        <p:nvSpPr>
-          <p:cNvPr id="3" name="Text 1"/>
-          <p:cNvSpPr/>
-          <p:nvPr/>
-        </p:nvSpPr>
-        <p:spPr>
-          <a:xfrm>
-            <a:off x="977494" y="368503"/>
-            <a:ext cx="5715000" cy="202997"/>
-          </a:xfrm>
-          <a:prstGeom prst="rect">
-            <a:avLst/>
-          </a:prstGeom>
-          <a:noFill/>
-          <a:ln/>
-        </p:spPr>
-        <p:txBody>
-          <a:bodyPr wrap="square" rtlCol="0" anchor="ctr"/>
-          <a:lstStyle/>
-          <a:p>
-            <a:pPr indent="0" marL="0">
-              <a:buNone/>
-            </a:pPr>
-            <a:r>
-              <a:rPr lang="en-US" sz="1000" b="1" spc="300" kern="0" dirty="0">
-                <a:solidFill>
-                  <a:srgbClr val="B5392A"/>
-                </a:solidFill>
-                <a:latin typeface="Inter" pitchFamily="34" charset="0"/>
-                <a:ea typeface="Inter" pitchFamily="34" charset="-122"/>
-                <a:cs typeface="Inter" pitchFamily="34" charset="-120"/>
-              </a:rPr>
-              <a:t>BACKUP</a:t>
-            </a:r>
-            <a:endParaRPr lang="en-US" sz="1000" dirty="0"/>
-          </a:p>
-        </p:txBody>
-      </p:sp>
-      <p:sp>
-        <p:nvSpPr>
-          <p:cNvPr id="4" name="Text 2"/>
-          <p:cNvSpPr/>
-          <p:nvPr/>
-        </p:nvSpPr>
-        <p:spPr>
-          <a:xfrm>
-            <a:off x="584302" y="609905"/>
-            <a:ext cx="10159898" cy="495605"/>
-          </a:xfrm>
-          <a:prstGeom prst="rect">
-            <a:avLst/>
-          </a:prstGeom>
-          <a:noFill/>
-          <a:ln/>
-        </p:spPr>
-        <p:txBody>
-          <a:bodyPr wrap="square" rtlCol="0" anchor="t"/>
-          <a:lstStyle/>
-          <a:p>
-            <a:pPr indent="0" marL="0">
-              <a:buNone/>
-            </a:pPr>
-            <a:r>
-              <a:rPr lang="en-US" sz="3100" b="1" dirty="0">
-                <a:solidFill>
-                  <a:srgbClr val="1A1714"/>
-                </a:solidFill>
-                <a:latin typeface="Playfair Display" pitchFamily="34" charset="0"/>
-                <a:ea typeface="Playfair Display" pitchFamily="34" charset="-122"/>
-                <a:cs typeface="Playfair Display" pitchFamily="34" charset="-120"/>
-              </a:rPr>
-              <a:t>Extra Diagnostics, Other Three Riders</a:t>
-            </a:r>
-            <a:endParaRPr lang="en-US" sz="3100" dirty="0"/>
-          </a:p>
-        </p:txBody>
-      </p:sp>
-      <p:sp>
-        <p:nvSpPr>
-          <p:cNvPr id="5" name="Shape 3"/>
-          <p:cNvSpPr/>
-          <p:nvPr/>
-        </p:nvSpPr>
-        <p:spPr>
-          <a:xfrm>
-            <a:off x="584302" y="1155802"/>
-            <a:ext cx="952805" cy="32004"/>
-          </a:xfrm>
-          <a:prstGeom prst="rect">
-            <a:avLst/>
-          </a:prstGeom>
-          <a:solidFill>
-            <a:srgbClr val="B5392A"/>
-          </a:solidFill>
-          <a:ln/>
-        </p:spPr>
-        <p:txBody>
-          <a:bodyPr/>
-          <a:p/>
-        </p:txBody>
-      </p:sp>
-      <p:sp>
-        <p:nvSpPr>
-          <p:cNvPr id="6" name="Text 4"/>
-          <p:cNvSpPr/>
-          <p:nvPr/>
-        </p:nvSpPr>
-        <p:spPr>
-          <a:xfrm>
-            <a:off x="584302" y="1498702"/>
-            <a:ext cx="11024006" cy="355702"/>
-          </a:xfrm>
-          <a:prstGeom prst="rect">
-            <a:avLst/>
-          </a:prstGeom>
-          <a:noFill/>
-          <a:ln/>
-        </p:spPr>
-        <p:txBody>
-          <a:bodyPr wrap="square" rtlCol="0" anchor="t"/>
-          <a:lstStyle/>
-          <a:p>
-            <a:pPr indent="0" marL="0">
-              <a:lnSpc>
-                <a:spcPct val="125000"/>
-              </a:lnSpc>
-              <a:buNone/>
-            </a:pPr>
-            <a:r>
-              <a:rPr lang="en-US" sz="1300" dirty="0">
-                <a:solidFill>
-                  <a:srgbClr val="1A1714"/>
-                </a:solidFill>
-                <a:latin typeface="Inter" pitchFamily="34" charset="0"/>
-                <a:ea typeface="Inter" pitchFamily="34" charset="-122"/>
-                <a:cs typeface="Inter" pitchFamily="34" charset="-120"/>
-              </a:rPr>
-              <a:t>Same 5-panel layout · strategy identical across all four profiles · climbers lower power, lose time on flats · women finish a few min back · Tokyo: men 2 laps, women 1 lap · one lap: f_tt 33.7 · m_clm 32.2 · f_clm 36.0 min</a:t>
-            </a:r>
-            <a:endParaRPr lang="en-US" sz="1300" dirty="0"/>
-          </a:p>
-        </p:txBody>
-      </p:sp>
-      <p:sp>
-        <p:nvSpPr>
-          <p:cNvPr id="7" name="Shape 5"/>
-          <p:cNvSpPr/>
-          <p:nvPr/>
-        </p:nvSpPr>
-        <p:spPr>
-          <a:xfrm>
-            <a:off x="584302" y="2031797"/>
-            <a:ext cx="3564331" cy="3556102"/>
-          </a:xfrm>
-          <a:prstGeom prst="rect">
-            <a:avLst/>
-          </a:prstGeom>
-          <a:solidFill>
-            <a:srgbClr val="FFFFFF"/>
-          </a:solidFill>
-          <a:ln w="25400">
-            <a:solidFill>
-              <a:srgbClr val="1A1714"/>
-            </a:solidFill>
-            <a:prstDash val="solid"/>
-          </a:ln>
-        </p:spPr>
-        <p:txBody>
-          <a:bodyPr/>
-          <a:p/>
-        </p:txBody>
-      </p:sp>
-      <p:pic>
-        <p:nvPicPr>
-          <p:cNvPr id="8" name="Image 0" descr="mq569llb-diag_female_tt.png">    </p:cNvPr>
-          <p:cNvPicPr>
-            <a:picLocks noChangeAspect="1"/>
-          </p:cNvPicPr>
-          <p:nvPr/>
-        </p:nvPicPr>
-        <p:blipFill>
-          <a:blip r:embed="rId1"/>
-          <a:stretch>
-            <a:fillRect/>
-          </a:stretch>
-        </p:blipFill>
-        <p:spPr>
-          <a:xfrm>
-            <a:off x="1004926" y="2146097"/>
-            <a:ext cx="2722169" cy="3327502"/>
-          </a:xfrm>
-          <a:prstGeom prst="rect">
-            <a:avLst/>
-          </a:prstGeom>
-        </p:spPr>
-      </p:pic>
-      <p:sp>
-        <p:nvSpPr>
-          <p:cNvPr id="9" name="Text 6"/>
-          <p:cNvSpPr/>
-          <p:nvPr/>
-        </p:nvSpPr>
-        <p:spPr>
-          <a:xfrm>
-            <a:off x="584302" y="5639105"/>
-            <a:ext cx="1913839" cy="330098"/>
-          </a:xfrm>
-          <a:prstGeom prst="rect">
-            <a:avLst/>
-          </a:prstGeom>
-          <a:noFill/>
-          <a:ln/>
-        </p:spPr>
-        <p:txBody>
-          <a:bodyPr wrap="square" rtlCol="0" anchor="t"/>
-          <a:lstStyle/>
-          <a:p>
-            <a:pPr indent="0" marL="0">
-              <a:lnSpc>
-                <a:spcPct val="120000"/>
-              </a:lnSpc>
-              <a:buNone/>
-            </a:pPr>
-            <a:r>
-              <a:rPr lang="en-US" sz="1000" dirty="0">
-                <a:solidFill>
-                  <a:srgbClr val="6B6258"/>
-                </a:solidFill>
-                <a:latin typeface="Inter" pitchFamily="34" charset="0"/>
-                <a:ea typeface="Inter" pitchFamily="34" charset="-122"/>
-                <a:cs typeface="Inter" pitchFamily="34" charset="-120"/>
-              </a:rPr>
-              <a:t>Female TT specialist</a:t>
-            </a:r>
-            <a:endParaRPr lang="en-US" sz="1000" dirty="0"/>
-          </a:p>
-        </p:txBody>
-      </p:sp>
-      <p:sp>
-        <p:nvSpPr>
-          <p:cNvPr id="11" name="Shape 8"/>
-          <p:cNvSpPr/>
-          <p:nvPr/>
-        </p:nvSpPr>
-        <p:spPr>
-          <a:xfrm>
-            <a:off x="4314139" y="2031797"/>
-            <a:ext cx="3564331" cy="3556102"/>
-          </a:xfrm>
-          <a:prstGeom prst="rect">
-            <a:avLst/>
-          </a:prstGeom>
-          <a:solidFill>
-            <a:srgbClr val="FFFFFF"/>
-          </a:solidFill>
-          <a:ln w="25400">
-            <a:solidFill>
-              <a:srgbClr val="1A1714"/>
-            </a:solidFill>
-            <a:prstDash val="solid"/>
-          </a:ln>
-        </p:spPr>
-        <p:txBody>
-          <a:bodyPr/>
-          <a:p/>
-        </p:txBody>
-      </p:sp>
-      <p:pic>
-        <p:nvPicPr>
-          <p:cNvPr id="12" name="Image 1" descr="mq569llc-diag_male_climber.png">    </p:cNvPr>
-          <p:cNvPicPr>
-            <a:picLocks noChangeAspect="1"/>
-          </p:cNvPicPr>
-          <p:nvPr/>
-        </p:nvPicPr>
-        <p:blipFill>
-          <a:blip r:embed="rId2"/>
-          <a:stretch>
-            <a:fillRect/>
-          </a:stretch>
-        </p:blipFill>
-        <p:spPr>
-          <a:xfrm>
-            <a:off x="4734763" y="2146097"/>
-            <a:ext cx="2722169" cy="3327502"/>
-          </a:xfrm>
-          <a:prstGeom prst="rect">
-            <a:avLst/>
-          </a:prstGeom>
-        </p:spPr>
-      </p:pic>
-      <p:sp>
-        <p:nvSpPr>
-          <p:cNvPr id="13" name="Text 9"/>
-          <p:cNvSpPr/>
-          <p:nvPr/>
-        </p:nvSpPr>
-        <p:spPr>
-          <a:xfrm>
-            <a:off x="4314139" y="5639105"/>
-            <a:ext cx="1913839" cy="330098"/>
-          </a:xfrm>
-          <a:prstGeom prst="rect">
-            <a:avLst/>
-          </a:prstGeom>
-          <a:noFill/>
-          <a:ln/>
-        </p:spPr>
-        <p:txBody>
-          <a:bodyPr wrap="square" rtlCol="0" anchor="t"/>
-          <a:lstStyle/>
-          <a:p>
-            <a:pPr indent="0" marL="0">
-              <a:lnSpc>
-                <a:spcPct val="120000"/>
-              </a:lnSpc>
-              <a:buNone/>
-            </a:pPr>
-            <a:r>
-              <a:rPr lang="en-US" sz="1000" dirty="0">
-                <a:solidFill>
-                  <a:srgbClr val="6B6258"/>
-                </a:solidFill>
-                <a:latin typeface="Inter" pitchFamily="34" charset="0"/>
-                <a:ea typeface="Inter" pitchFamily="34" charset="-122"/>
-                <a:cs typeface="Inter" pitchFamily="34" charset="-120"/>
-              </a:rPr>
-              <a:t>Male climber</a:t>
-            </a:r>
-            <a:endParaRPr lang="en-US" sz="1000" dirty="0"/>
-          </a:p>
-        </p:txBody>
-      </p:sp>
-      <p:sp>
-        <p:nvSpPr>
-          <p:cNvPr id="15" name="Shape 11"/>
-          <p:cNvSpPr/>
-          <p:nvPr/>
-        </p:nvSpPr>
-        <p:spPr>
-          <a:xfrm>
-            <a:off x="8043062" y="2031797"/>
-            <a:ext cx="3564331" cy="3556102"/>
-          </a:xfrm>
-          <a:prstGeom prst="rect">
-            <a:avLst/>
-          </a:prstGeom>
-          <a:solidFill>
-            <a:srgbClr val="FFFFFF"/>
-          </a:solidFill>
-          <a:ln w="25400">
-            <a:solidFill>
-              <a:srgbClr val="1A1714"/>
-            </a:solidFill>
-            <a:prstDash val="solid"/>
-          </a:ln>
-        </p:spPr>
-        <p:txBody>
-          <a:bodyPr/>
-          <a:p/>
-        </p:txBody>
-      </p:sp>
-      <p:pic>
-        <p:nvPicPr>
-          <p:cNvPr id="16" name="Image 2" descr="mq569llb-diag_female_climber.png">    </p:cNvPr>
-          <p:cNvPicPr>
-            <a:picLocks noChangeAspect="1"/>
-          </p:cNvPicPr>
-          <p:nvPr/>
-        </p:nvPicPr>
-        <p:blipFill>
-          <a:blip r:embed="rId3"/>
-          <a:stretch>
-            <a:fillRect/>
-          </a:stretch>
-        </p:blipFill>
-        <p:spPr>
-          <a:xfrm>
-            <a:off x="8464601" y="2146097"/>
-            <a:ext cx="2722169" cy="3327502"/>
-          </a:xfrm>
-          <a:prstGeom prst="rect">
-            <a:avLst/>
-          </a:prstGeom>
-        </p:spPr>
-      </p:pic>
-      <p:sp>
-        <p:nvSpPr>
-          <p:cNvPr id="17" name="Text 12"/>
-          <p:cNvSpPr/>
-          <p:nvPr/>
-        </p:nvSpPr>
-        <p:spPr>
-          <a:xfrm>
-            <a:off x="8043062" y="5639105"/>
-            <a:ext cx="1913839" cy="330098"/>
-          </a:xfrm>
-          <a:prstGeom prst="rect">
-            <a:avLst/>
-          </a:prstGeom>
-          <a:noFill/>
-          <a:ln/>
-        </p:spPr>
-        <p:txBody>
-          <a:bodyPr wrap="square" rtlCol="0" anchor="t"/>
-          <a:lstStyle/>
-          <a:p>
-            <a:pPr indent="0" marL="0">
-              <a:lnSpc>
-                <a:spcPct val="120000"/>
-              </a:lnSpc>
-              <a:buNone/>
-            </a:pPr>
-            <a:r>
-              <a:rPr lang="en-US" sz="1000" dirty="0">
-                <a:solidFill>
-                  <a:srgbClr val="6B6258"/>
-                </a:solidFill>
-                <a:latin typeface="Inter" pitchFamily="34" charset="0"/>
-                <a:ea typeface="Inter" pitchFamily="34" charset="-122"/>
-                <a:cs typeface="Inter" pitchFamily="34" charset="-120"/>
-              </a:rPr>
-              <a:t>Female climber</a:t>
-            </a:r>
-            <a:endParaRPr lang="en-US" sz="1000" dirty="0"/>
-          </a:p>
-        </p:txBody>
-      </p:sp>
-      <p:sp>
-        <p:nvSpPr>
-          <p:cNvPr id="19" name="Text 14"/>
-          <p:cNvSpPr/>
-          <p:nvPr/>
-        </p:nvSpPr>
-        <p:spPr>
-          <a:xfrm>
-            <a:off x="584302" y="6096305"/>
-            <a:ext cx="11024006" cy="177394"/>
-          </a:xfrm>
-          <a:prstGeom prst="rect">
-            <a:avLst/>
-          </a:prstGeom>
-          <a:noFill/>
-          <a:ln/>
-        </p:spPr>
-        <p:txBody>
-          <a:bodyPr wrap="square" rtlCol="0" anchor="ctr"/>
-          <a:lstStyle/>
-          <a:p>
-            <a:pPr indent="0" marL="0">
-              <a:buNone/>
-            </a:pPr>
-            <a:r>
-              <a:rPr lang="en-US" sz="1100" dirty="0">
-                <a:solidFill>
-                  <a:srgbClr val="6B6258"/>
-                </a:solidFill>
-                <a:latin typeface="Inter" pitchFamily="34" charset="0"/>
-                <a:ea typeface="Inter" pitchFamily="34" charset="-122"/>
-                <a:cs typeface="Inter" pitchFamily="34" charset="-120"/>
-              </a:rPr>
-              <a:t>Optimal vs baseline pacing, female TT, male climber, female climber (Tokyo)</a:t>
-            </a:r>
-            <a:endParaRPr lang="en-US" sz="1100" dirty="0"/>
-          </a:p>
-        </p:txBody>
-      </p:sp>
-      <p:sp>
-        <p:nvSpPr>
-          <p:cNvPr id="20" name="Shape 15"/>
-          <p:cNvSpPr/>
-          <p:nvPr/>
-        </p:nvSpPr>
-        <p:spPr>
-          <a:xfrm>
-            <a:off x="584302" y="6349594"/>
-            <a:ext cx="11024006" cy="0"/>
-          </a:xfrm>
-          <a:prstGeom prst="line">
-            <a:avLst/>
-          </a:prstGeom>
-          <a:noFill/>
-          <a:ln w="25400">
-            <a:solidFill>
-              <a:srgbClr val="1A1714"/>
-            </a:solidFill>
-            <a:prstDash val="solid"/>
-          </a:ln>
-        </p:spPr>
-        <p:txBody>
-          <a:bodyPr/>
-          <a:p/>
-        </p:txBody>
-      </p:sp>
-      <p:sp>
-        <p:nvSpPr>
-          <p:cNvPr id="21" name="Text 16"/>
-          <p:cNvSpPr/>
-          <p:nvPr/>
-        </p:nvSpPr>
-        <p:spPr>
-          <a:xfrm>
-            <a:off x="584302" y="6400800"/>
-            <a:ext cx="5715000" cy="177394"/>
-          </a:xfrm>
-          <a:prstGeom prst="rect">
-            <a:avLst/>
-          </a:prstGeom>
-          <a:noFill/>
-          <a:ln/>
-        </p:spPr>
-        <p:txBody>
-          <a:bodyPr wrap="square" rtlCol="0" anchor="ctr"/>
-          <a:lstStyle/>
-          <a:p>
-            <a:pPr indent="0" marL="0">
-              <a:buNone/>
-            </a:pPr>
-            <a:r>
-              <a:rPr lang="en-US" sz="1050" dirty="0">
-                <a:solidFill>
-                  <a:srgbClr val="6B6258"/>
-                </a:solidFill>
-                <a:latin typeface="Inter" pitchFamily="34" charset="0"/>
-                <a:ea typeface="Inter" pitchFamily="34" charset="-122"/>
-                <a:cs typeface="Inter" pitchFamily="34" charset="-120"/>
-              </a:rPr>
-              <a:t>Power Profile of a Cyclist · Backup</a:t>
-            </a:r>
-            <a:endParaRPr lang="en-US" sz="1050" dirty="0"/>
-          </a:p>
-        </p:txBody>
-      </p:sp>
-      <p:sp>
-        <p:nvSpPr>
-          <p:cNvPr id="22" name="Text 17"/>
-          <p:cNvSpPr/>
-          <p:nvPr/>
-        </p:nvSpPr>
-        <p:spPr>
-          <a:xfrm>
-            <a:off x="9702698" y="6400800"/>
-            <a:ext cx="1904695" cy="177394"/>
-          </a:xfrm>
-          <a:prstGeom prst="rect">
-            <a:avLst/>
-          </a:prstGeom>
-          <a:noFill/>
-          <a:ln/>
-        </p:spPr>
-        <p:txBody>
-          <a:bodyPr wrap="square" rtlCol="0" anchor="ctr"/>
-          <a:lstStyle/>
-          <a:p>
-            <a:pPr algn="r" indent="0" marL="0">
-              <a:buNone/>
-            </a:pPr>
-            <a:r>
-              <a:rPr lang="en-US" sz="1050" b="1" spc="200" kern="0" dirty="0">
-                <a:solidFill>
-                  <a:srgbClr val="B5392A"/>
-                </a:solidFill>
-                <a:latin typeface="JetBrains Mono" pitchFamily="34" charset="0"/>
-                <a:ea typeface="JetBrains Mono" pitchFamily="34" charset="-122"/>
-                <a:cs typeface="JetBrains Mono" pitchFamily="34" charset="-120"/>
-              </a:rPr>
-              <a:t>B2</a:t>
-            </a:r>
-            <a:pPr algn="r" indent="0" marL="0">
-              <a:buNone/>
-            </a:pPr>
-            <a:endParaRPr lang="en-US" sz="1050" dirty="0"/>
-          </a:p>
-        </p:txBody>
-      </p:sp>
-    </p:spTree>
-  </p:cSld>
-  <p:clrMapOvr>
-    <a:masterClrMapping/>
-  </p:clrMapOvr>
-</p:sld>
-</file>
-
-<file path=ppt/slides/slide18.xml><?xml version="1.0" encoding="utf-8"?>
 <p:sld xmlns:a="http://schemas.openxmlformats.org/drawingml/2006/main" xmlns:r="http://schemas.openxmlformats.org/officeDocument/2006/relationships" xmlns:p="http://schemas.openxmlformats.org/presentationml/2006/main">
   <p:cSld name="Slide 18">
     <p:spTree>
@@ -12181,7 +10420,7 @@
                 <a:ea typeface="JetBrains Mono" pitchFamily="34" charset="-122"/>
                 <a:cs typeface="JetBrains Mono" pitchFamily="34" charset="-120"/>
               </a:rPr>
-              <a:t>HEADLINE</a:t>
+              <a:t>KEY TAKEAWAY</a:t>
             </a:r>
             <a:endParaRPr lang="en-US" sz="850" dirty="0"/>
           </a:p>
@@ -12871,6 +11110,40 @@
           </a:prstGeom>
         </p:spPr>
       </p:pic>
+      <p:sp>
+        <p:nvSpPr>
+          <p:cNvPr id="27" name="TextBox 26"/>
+          <p:cNvSpPr txBox="1"/>
+          <p:nvPr/>
+        </p:nvSpPr>
+        <p:spPr>
+          <a:xfrm>
+            <a:off x="6172200" y="5221224"/>
+            <a:ext cx="5486400" cy="320040"/>
+          </a:xfrm>
+          <a:prstGeom prst="rect">
+            <a:avLst/>
+          </a:prstGeom>
+          <a:noFill/>
+        </p:spPr>
+        <p:txBody>
+          <a:bodyPr wrap="square">
+            <a:noAutofit/>
+          </a:bodyPr>
+          <a:lstStyle/>
+          <a:p>
+            <a:r>
+              <a:rPr sz="1050">
+                <a:solidFill>
+                  <a:srgbClr val="6B6258"/>
+                </a:solidFill>
+                <a:latin typeface="Inter"/>
+              </a:rPr>
+              <a:t>What this shows: darker = faster; the wide dark zone means many knob settings nearly tie.</a:t>
+            </a:r>
+          </a:p>
+        </p:txBody>
+      </p:sp>
     </p:spTree>
   </p:cSld>
   <p:clrMapOvr>

</xml_diff>

<commit_message>
Remove the team time trial extension slide; renumber to 14 main slides
</commit_message>
<xml_diff>
--- a/presentation/Math142_Presentation.pptx
+++ b/presentation/Math142_Presentation.pptx
@@ -18,7 +18,6 @@
     <p:sldId id="266" r:id="rId12"/>
     <p:sldId id="267" r:id="rId13"/>
     <p:sldId id="268" r:id="rId14"/>
-    <p:sldId id="269" r:id="rId15"/>
     <p:sldId id="270" r:id="rId16"/>
     <p:sldId id="273" r:id="rId19"/>
   </p:sldIdLst>
@@ -913,99 +912,6 @@
             <a:fld id="{F7021451-1387-4CA6-816F-3879F97B5CBC}" type="slidenum">
               <a:rPr lang="en-US"/>
               <a:t>13</a:t>
-            </a:fld>
-            <a:endParaRPr lang="en-US"/>
-          </a:p>
-        </p:txBody>
-      </p:sp>
-    </p:spTree>
-    <p:extLst>
-      <p:ext uri="{BB962C8B-B14F-4D97-AF65-F5344CB8AC3E}">
-        <p14:creationId xmlns:p14="http://schemas.microsoft.com/office/powerpoint/2010/main" val="1024086991"/>
-      </p:ext>
-    </p:extLst>
-  </p:cSld>
-  <p:clrMapOvr>
-    <a:masterClrMapping/>
-  </p:clrMapOvr>
-</p:notes>
-</file>
-
-<file path=ppt/notesSlides/notesSlide14.xml><?xml version="1.0" encoding="utf-8"?>
-<p:notes xmlns:a="http://schemas.openxmlformats.org/drawingml/2006/main" xmlns:r="http://schemas.openxmlformats.org/officeDocument/2006/relationships" xmlns:p="http://schemas.openxmlformats.org/presentationml/2006/main">
-  <p:cSld>
-    <p:spTree>
-      <p:nvGrpSpPr>
-        <p:cNvPr id="1" name=""/>
-        <p:cNvGrpSpPr/>
-        <p:nvPr/>
-      </p:nvGrpSpPr>
-      <p:grpSpPr>
-        <a:xfrm>
-          <a:off x="0" y="0"/>
-          <a:ext cx="0" cy="0"/>
-          <a:chOff x="0" y="0"/>
-          <a:chExt cx="0" cy="0"/>
-        </a:xfrm>
-      </p:grpSpPr>
-      <p:sp>
-        <p:nvSpPr>
-          <p:cNvPr id="2" name="Slide Image Placeholder 1"/>
-          <p:cNvSpPr>
-            <a:spLocks noGrp="1" noRot="1" noChangeAspect="1"/>
-          </p:cNvSpPr>
-          <p:nvPr>
-            <p:ph type="sldImg"/>
-          </p:nvPr>
-        </p:nvSpPr>
-        <p:spPr/>
-      </p:sp>
-      <p:sp>
-        <p:nvSpPr>
-          <p:cNvPr id="3" name="Notes Placeholder 2"/>
-          <p:cNvSpPr>
-            <a:spLocks noGrp="1"/>
-          </p:cNvSpPr>
-          <p:nvPr>
-            <p:ph type="body" idx="1"/>
-          </p:nvPr>
-        </p:nvSpPr>
-        <p:spPr/>
-        <p:txBody>
-          <a:bodyPr/>
-          <a:lstStyle/>
-          <a:p>
-            <a:r>
-              <a:rPr lang="en-US" dirty="0"/>
-              <a:t>The single-rider model already has the two pieces a TTT needs — a per-rider drag area and a per-rider fatigue budget.</a:t>
-            </a:r>
-            <a:endParaRPr lang="en-US" dirty="0"/>
-          </a:p>
-          <a:p>
-            <a:r>
-              <a:t>Detail: extends our model by scaling a sheltered rider's CdA by a draft factor and dropping the weakest once four can still finish — it already carries per-rider CdA and per-rider fatigue.</a:t>
-            </a:r>
-          </a:p>
-        </p:txBody>
-      </p:sp>
-      <p:sp>
-        <p:nvSpPr>
-          <p:cNvPr id="4" name="Slide Number Placeholder 3"/>
-          <p:cNvSpPr>
-            <a:spLocks noGrp="1"/>
-          </p:cNvSpPr>
-          <p:nvPr>
-            <p:ph type="sldNum" sz="quarter" idx="10"/>
-          </p:nvPr>
-        </p:nvSpPr>
-        <p:spPr/>
-        <p:txBody>
-          <a:bodyPr/>
-          <a:lstStyle/>
-          <a:p>
-            <a:fld id="{F7021451-1387-4CA6-816F-3879F97B5CBC}" type="slidenum">
-              <a:rPr lang="en-US"/>
-              <a:t>14</a:t>
             </a:fld>
             <a:endParaRPr lang="en-US"/>
           </a:p>
@@ -3297,7 +3203,7 @@
                 <a:ea typeface="JetBrains Mono" pitchFamily="34" charset="-122"/>
                 <a:cs typeface="JetBrains Mono" pitchFamily="34" charset="-120"/>
               </a:rPr>
-              <a:t> / 15</a:t>
+              <a:t> / 14</a:t>
             </a:r>
             <a:endParaRPr lang="en-US" sz="1050" dirty="0"/>
           </a:p>
@@ -3926,7 +3832,7 @@
                 <a:ea typeface="JetBrains Mono" pitchFamily="34" charset="-122"/>
                 <a:cs typeface="JetBrains Mono" pitchFamily="34" charset="-120"/>
               </a:rPr>
-              <a:t> / 15</a:t>
+              <a:t> / 14</a:t>
             </a:r>
             <a:endParaRPr lang="en-US" sz="1050" dirty="0"/>
           </a:p>
@@ -4457,7 +4363,7 @@
                 <a:ea typeface="JetBrains Mono" pitchFamily="34" charset="-122"/>
                 <a:cs typeface="JetBrains Mono" pitchFamily="34" charset="-120"/>
               </a:rPr>
-              <a:t> / 15</a:t>
+              <a:t> / 14</a:t>
             </a:r>
             <a:endParaRPr lang="en-US" sz="1050" dirty="0"/>
           </a:p>
@@ -5068,586 +4974,9 @@
                 <a:ea typeface="JetBrains Mono" pitchFamily="34" charset="-122"/>
                 <a:cs typeface="JetBrains Mono" pitchFamily="34" charset="-120"/>
               </a:rPr>
-              <a:t> / 15</a:t>
+              <a:t> / 14</a:t>
             </a:r>
             <a:endParaRPr lang="en-US" sz="1050" dirty="0"/>
-          </a:p>
-        </p:txBody>
-      </p:sp>
-    </p:spTree>
-  </p:cSld>
-  <p:clrMapOvr>
-    <a:masterClrMapping/>
-  </p:clrMapOvr>
-</p:sld>
-</file>
-
-<file path=ppt/slides/slide14.xml><?xml version="1.0" encoding="utf-8"?>
-<p:sld xmlns:a="http://schemas.openxmlformats.org/drawingml/2006/main" xmlns:r="http://schemas.openxmlformats.org/officeDocument/2006/relationships" xmlns:p="http://schemas.openxmlformats.org/presentationml/2006/main">
-  <p:cSld name="Slide 14">
-    <p:spTree>
-      <p:nvGrpSpPr>
-        <p:cNvPr id="1" name=""/>
-        <p:cNvGrpSpPr/>
-        <p:nvPr/>
-      </p:nvGrpSpPr>
-      <p:grpSpPr>
-        <a:xfrm>
-          <a:off x="0" y="0"/>
-          <a:ext cx="0" cy="0"/>
-          <a:chOff x="0" y="0"/>
-          <a:chExt cx="0" cy="0"/>
-        </a:xfrm>
-      </p:grpSpPr>
-      <p:sp>
-        <p:nvSpPr>
-          <p:cNvPr id="2" name="Text 0"/>
-          <p:cNvSpPr/>
-          <p:nvPr/>
-        </p:nvSpPr>
-        <p:spPr>
-          <a:xfrm>
-            <a:off x="548640" y="338328"/>
-            <a:ext cx="365760" cy="256032"/>
-          </a:xfrm>
-          <a:prstGeom prst="rect">
-            <a:avLst/>
-          </a:prstGeom>
-          <a:solidFill>
-            <a:srgbClr val="B5392A"/>
-          </a:solidFill>
-          <a:ln w="25400">
-            <a:solidFill>
-              <a:srgbClr val="1A1714"/>
-            </a:solidFill>
-          </a:ln>
-        </p:spPr>
-        <p:txBody>
-          <a:bodyPr wrap="none" rtlCol="0" anchor="ctr" lIns="0" rIns="0" tIns="0" bIns="0"/>
-          <a:lstStyle/>
-          <a:p>
-            <a:pPr algn="ctr" indent="0" marL="0">
-              <a:buNone/>
-            </a:pPr>
-            <a:r>
-              <a:rPr lang="en-US" sz="1100" dirty="0">
-                <a:solidFill>
-                  <a:srgbClr val="F0EAE0"/>
-                </a:solidFill>
-                <a:latin typeface="JetBrains Mono" pitchFamily="34" charset="0"/>
-                <a:ea typeface="JetBrains Mono" pitchFamily="34" charset="-122"/>
-                <a:cs typeface="JetBrains Mono" pitchFamily="34" charset="-120"/>
-              </a:rPr>
-              <a:t>14</a:t>
-            </a:r>
-            <a:endParaRPr lang="en-US" sz="1300" dirty="0"/>
-          </a:p>
-        </p:txBody>
-      </p:sp>
-      <p:sp>
-        <p:nvSpPr>
-          <p:cNvPr id="3" name="Text 1"/>
-          <p:cNvSpPr/>
-          <p:nvPr/>
-        </p:nvSpPr>
-        <p:spPr>
-          <a:xfrm>
-            <a:off x="977494" y="368503"/>
-            <a:ext cx="5715000" cy="202997"/>
-          </a:xfrm>
-          <a:prstGeom prst="rect">
-            <a:avLst/>
-          </a:prstGeom>
-          <a:noFill/>
-          <a:ln/>
-        </p:spPr>
-        <p:txBody>
-          <a:bodyPr wrap="square" rtlCol="0" anchor="ctr"/>
-          <a:lstStyle/>
-          <a:p>
-            <a:pPr indent="0" marL="0">
-              <a:buNone/>
-            </a:pPr>
-            <a:r>
-              <a:rPr lang="en-US" sz="1000" b="1" spc="300" kern="0" dirty="0">
-                <a:solidFill>
-                  <a:srgbClr val="B5392A"/>
-                </a:solidFill>
-                <a:latin typeface="Inter" pitchFamily="34" charset="0"/>
-                <a:ea typeface="Inter" pitchFamily="34" charset="-122"/>
-                <a:cs typeface="Inter" pitchFamily="34" charset="-120"/>
-              </a:rPr>
-              <a:t>EXTENSION</a:t>
-            </a:r>
-            <a:endParaRPr lang="en-US" sz="1000" dirty="0"/>
-          </a:p>
-        </p:txBody>
-      </p:sp>
-      <p:sp>
-        <p:nvSpPr>
-          <p:cNvPr id="4" name="Text 2"/>
-          <p:cNvSpPr/>
-          <p:nvPr/>
-        </p:nvSpPr>
-        <p:spPr>
-          <a:xfrm>
-            <a:off x="584302" y="609905"/>
-            <a:ext cx="10159898" cy="495605"/>
-          </a:xfrm>
-          <a:prstGeom prst="rect">
-            <a:avLst/>
-          </a:prstGeom>
-          <a:noFill/>
-          <a:ln/>
-        </p:spPr>
-        <p:txBody>
-          <a:bodyPr wrap="square" rtlCol="0" anchor="t"/>
-          <a:lstStyle/>
-          <a:p>
-            <a:pPr indent="0" marL="0">
-              <a:buNone/>
-            </a:pPr>
-            <a:r>
-              <a:rPr lang="en-US" sz="3100" b="1" dirty="0">
-                <a:solidFill>
-                  <a:srgbClr val="1A1714"/>
-                </a:solidFill>
-                <a:latin typeface="Playfair Display" pitchFamily="34" charset="0"/>
-                <a:ea typeface="Playfair Display" pitchFamily="34" charset="-122"/>
-                <a:cs typeface="Playfair Display" pitchFamily="34" charset="-120"/>
-              </a:rPr>
-              <a:t>Extension: Team Time Trial</a:t>
-            </a:r>
-            <a:endParaRPr lang="en-US" sz="3100" dirty="0"/>
-          </a:p>
-        </p:txBody>
-      </p:sp>
-      <p:sp>
-        <p:nvSpPr>
-          <p:cNvPr id="5" name="Shape 3"/>
-          <p:cNvSpPr/>
-          <p:nvPr/>
-        </p:nvSpPr>
-        <p:spPr>
-          <a:xfrm>
-            <a:off x="584302" y="1155802"/>
-            <a:ext cx="952805" cy="32004"/>
-          </a:xfrm>
-          <a:prstGeom prst="rect">
-            <a:avLst/>
-          </a:prstGeom>
-          <a:solidFill>
-            <a:srgbClr val="B5392A"/>
-          </a:solidFill>
-          <a:ln/>
-        </p:spPr>
-        <p:txBody>
-          <a:bodyPr/>
-          <a:p/>
-        </p:txBody>
-      </p:sp>
-      <p:sp>
-        <p:nvSpPr>
-          <p:cNvPr id="6" name="Text 4"/>
-          <p:cNvSpPr/>
-          <p:nvPr/>
-        </p:nvSpPr>
-        <p:spPr>
-          <a:xfrm>
-            <a:off x="584302" y="1498702"/>
-            <a:ext cx="11024006" cy="761695"/>
-          </a:xfrm>
-          <a:prstGeom prst="rect">
-            <a:avLst/>
-          </a:prstGeom>
-          <a:noFill/>
-          <a:ln/>
-        </p:spPr>
-        <p:txBody>
-          <a:bodyPr wrap="square" rtlCol="0" anchor="t"/>
-          <a:lstStyle/>
-          <a:p>
-            <a:pPr indent="0" marL="0">
-              <a:lnSpc>
-                <a:spcPct val="118000"/>
-              </a:lnSpc>
-              <a:buNone/>
-            </a:pPr>
-            <a:r>
-              <a:rPr lang="en-US" sz="2000" b="1" dirty="0">
-                <a:solidFill>
-                  <a:srgbClr val="1A1714"/>
-                </a:solidFill>
-                <a:latin typeface="Playfair Display" pitchFamily="34" charset="0"/>
-                <a:ea typeface="Playfair Display" pitchFamily="34" charset="-122"/>
-                <a:cs typeface="Playfair Display" pitchFamily="34" charset="-120"/>
-              </a:rPr>
-              <a:t>The single-rider model already carries the two ingredients a TTT needs.</a:t>
-            </a:r>
-            <a:endParaRPr lang="en-US" sz="2000" dirty="0"/>
-          </a:p>
-        </p:txBody>
-      </p:sp>
-      <p:sp>
-        <p:nvSpPr>
-          <p:cNvPr id="7" name="Text 5"/>
-          <p:cNvSpPr/>
-          <p:nvPr/>
-        </p:nvSpPr>
-        <p:spPr>
-          <a:xfrm>
-            <a:off x="584302" y="2413102"/>
-            <a:ext cx="5969203" cy="2794406"/>
-          </a:xfrm>
-          <a:prstGeom prst="rect">
-            <a:avLst/>
-          </a:prstGeom>
-          <a:noFill/>
-          <a:ln/>
-        </p:spPr>
-        <p:txBody>
-          <a:bodyPr wrap="square" rtlCol="0" anchor="t"/>
-          <a:lstStyle/>
-          <a:p>
-            <a:pPr indent="0" marL="0">
-              <a:lnSpc>
-                <a:spcPct val="122000"/>
-              </a:lnSpc>
-              <a:spcAft>
-                <a:spcPts val="600"/>
-              </a:spcAft>
-              <a:buNone/>
-            </a:pPr>
-            <a:r>
-              <a:rPr lang="en-US" sz="1550" b="1" dirty="0">
-                <a:solidFill>
-                  <a:srgbClr val="B5392A"/>
-                </a:solidFill>
-                <a:latin typeface="Inter" pitchFamily="34" charset="0"/>
-                <a:ea typeface="Inter" pitchFamily="34" charset="-122"/>
-                <a:cs typeface="Inter" pitchFamily="34" charset="-120"/>
-              </a:rPr>
-              <a:t>■  Team's time = the 4th rider across the line</a:t>
-            </a:r>
-            <a:pPr indent="0" marL="0">
-              <a:lnSpc>
-                <a:spcPct val="122000"/>
-              </a:lnSpc>
-              <a:spcAft>
-                <a:spcPts val="600"/>
-              </a:spcAft>
-              <a:buNone/>
-            </a:pPr>
-            <a:pPr indent="0" marL="0">
-              <a:lnSpc>
-                <a:spcPct val="122000"/>
-              </a:lnSpc>
-              <a:spcAft>
-                <a:spcPts val="600"/>
-              </a:spcAft>
-              <a:buNone/>
-            </a:pPr>
-            <a:endParaRPr lang="en-US" sz="1550" dirty="0"/>
-          </a:p>
-          <a:p>
-            <a:pPr indent="0" marL="0">
-              <a:lnSpc>
-                <a:spcPct val="122000"/>
-              </a:lnSpc>
-              <a:spcAft>
-                <a:spcPts val="600"/>
-              </a:spcAft>
-              <a:buNone/>
-            </a:pPr>
-            <a:r>
-              <a:rPr lang="en-US" sz="1550" b="1" dirty="0">
-                <a:solidFill>
-                  <a:srgbClr val="B5392A"/>
-                </a:solidFill>
-                <a:latin typeface="Inter" pitchFamily="34" charset="0"/>
-                <a:ea typeface="Inter" pitchFamily="34" charset="-122"/>
-                <a:cs typeface="Inter" pitchFamily="34" charset="-120"/>
-              </a:rPr>
-              <a:t>■  New goal: keep four together as long as possible</a:t>
-            </a:r>
-            <a:pPr indent="0" marL="0">
-              <a:lnSpc>
-                <a:spcPct val="122000"/>
-              </a:lnSpc>
-              <a:spcAft>
-                <a:spcPts val="600"/>
-              </a:spcAft>
-              <a:buNone/>
-            </a:pPr>
-            <a:pPr indent="0" marL="0">
-              <a:lnSpc>
-                <a:spcPct val="122000"/>
-              </a:lnSpc>
-              <a:spcAft>
-                <a:spcPts val="600"/>
-              </a:spcAft>
-              <a:buNone/>
-            </a:pPr>
-            <a:endParaRPr lang="en-US" sz="1550" dirty="0"/>
-          </a:p>
-          <a:p>
-            <a:pPr indent="0" marL="0">
-              <a:lnSpc>
-                <a:spcPct val="122000"/>
-              </a:lnSpc>
-              <a:spcAft>
-                <a:spcPts val="600"/>
-              </a:spcAft>
-              <a:buNone/>
-            </a:pPr>
-            <a:r>
-              <a:rPr lang="en-US" sz="1550" b="1" dirty="0">
-                <a:solidFill>
-                  <a:srgbClr val="B5392A"/>
-                </a:solidFill>
-                <a:latin typeface="Inter" pitchFamily="34" charset="0"/>
-                <a:ea typeface="Inter" pitchFamily="34" charset="-122"/>
-                <a:cs typeface="Inter" pitchFamily="34" charset="-120"/>
-              </a:rPr>
-              <a:t>■  Drafting dominates: the slipstream cuts drag</a:t>
-            </a:r>
-            <a:pPr indent="0" marL="0">
-              <a:lnSpc>
-                <a:spcPct val="122000"/>
-              </a:lnSpc>
-              <a:spcAft>
-                <a:spcPts val="600"/>
-              </a:spcAft>
-              <a:buNone/>
-            </a:pPr>
-            <a:pPr indent="0" marL="0">
-              <a:lnSpc>
-                <a:spcPct val="122000"/>
-              </a:lnSpc>
-              <a:spcAft>
-                <a:spcPts val="600"/>
-              </a:spcAft>
-              <a:buNone/>
-            </a:pPr>
-            <a:endParaRPr lang="en-US" sz="1550" dirty="0"/>
-          </a:p>
-          <a:p>
-            <a:pPr indent="0" marL="0">
-              <a:lnSpc>
-                <a:spcPct val="122000"/>
-              </a:lnSpc>
-              <a:spcAft>
-                <a:spcPts val="600"/>
-              </a:spcAft>
-              <a:buNone/>
-            </a:pPr>
-            <a:r>
-              <a:rPr lang="en-US" sz="1550" b="1" dirty="0">
-                <a:solidFill>
-                  <a:srgbClr val="B5392A"/>
-                </a:solidFill>
-                <a:latin typeface="Inter" pitchFamily="34" charset="0"/>
-                <a:ea typeface="Inter" pitchFamily="34" charset="-122"/>
-                <a:cs typeface="Inter" pitchFamily="34" charset="-120"/>
-              </a:rPr>
-              <a:t>■  Rotating paceline: hard pull, then recover in the draft</a:t>
-            </a:r>
-            <a:pPr indent="0" marL="0">
-              <a:lnSpc>
-                <a:spcPct val="122000"/>
-              </a:lnSpc>
-              <a:spcAft>
-                <a:spcPts val="600"/>
-              </a:spcAft>
-              <a:buNone/>
-            </a:pPr>
-            <a:pPr indent="0" marL="0">
-              <a:lnSpc>
-                <a:spcPct val="122000"/>
-              </a:lnSpc>
-              <a:spcAft>
-                <a:spcPts val="600"/>
-              </a:spcAft>
-              <a:buNone/>
-            </a:pPr>
-            <a:endParaRPr lang="en-US" sz="1550" dirty="0"/>
-          </a:p>
-        </p:txBody>
-      </p:sp>
-      <p:sp>
-        <p:nvSpPr>
-          <p:cNvPr id="17" name="Shape 15"/>
-          <p:cNvSpPr/>
-          <p:nvPr/>
-        </p:nvSpPr>
-        <p:spPr>
-          <a:xfrm>
-            <a:off x="584302" y="6349594"/>
-            <a:ext cx="11024006" cy="0"/>
-          </a:xfrm>
-          <a:prstGeom prst="line">
-            <a:avLst/>
-          </a:prstGeom>
-          <a:noFill/>
-          <a:ln w="25400">
-            <a:solidFill>
-              <a:srgbClr val="1A1714"/>
-            </a:solidFill>
-            <a:prstDash val="solid"/>
-          </a:ln>
-        </p:spPr>
-        <p:txBody>
-          <a:bodyPr/>
-          <a:p/>
-        </p:txBody>
-      </p:sp>
-      <p:sp>
-        <p:nvSpPr>
-          <p:cNvPr id="18" name="Text 16"/>
-          <p:cNvSpPr/>
-          <p:nvPr/>
-        </p:nvSpPr>
-        <p:spPr>
-          <a:xfrm>
-            <a:off x="584302" y="6400800"/>
-            <a:ext cx="5715000" cy="177394"/>
-          </a:xfrm>
-          <a:prstGeom prst="rect">
-            <a:avLst/>
-          </a:prstGeom>
-          <a:noFill/>
-          <a:ln/>
-        </p:spPr>
-        <p:txBody>
-          <a:bodyPr wrap="square" rtlCol="0" anchor="ctr"/>
-          <a:lstStyle/>
-          <a:p>
-            <a:pPr indent="0" marL="0">
-              <a:buNone/>
-            </a:pPr>
-            <a:r>
-              <a:rPr lang="en-US" sz="1050" dirty="0">
-                <a:solidFill>
-                  <a:srgbClr val="6B6258"/>
-                </a:solidFill>
-                <a:latin typeface="Inter" pitchFamily="34" charset="0"/>
-                <a:ea typeface="Inter" pitchFamily="34" charset="-122"/>
-                <a:cs typeface="Inter" pitchFamily="34" charset="-120"/>
-              </a:rPr>
-              <a:t>Power Profile of a Cyclist</a:t>
-            </a:r>
-            <a:endParaRPr lang="en-US" sz="1050" dirty="0"/>
-          </a:p>
-        </p:txBody>
-      </p:sp>
-      <p:sp>
-        <p:nvSpPr>
-          <p:cNvPr id="19" name="Text 17"/>
-          <p:cNvSpPr/>
-          <p:nvPr/>
-        </p:nvSpPr>
-        <p:spPr>
-          <a:xfrm>
-            <a:off x="9702698" y="6400800"/>
-            <a:ext cx="1904695" cy="177394"/>
-          </a:xfrm>
-          <a:prstGeom prst="rect">
-            <a:avLst/>
-          </a:prstGeom>
-          <a:noFill/>
-          <a:ln/>
-        </p:spPr>
-        <p:txBody>
-          <a:bodyPr wrap="square" rtlCol="0" anchor="ctr"/>
-          <a:lstStyle/>
-          <a:p>
-            <a:pPr algn="r" indent="0" marL="0">
-              <a:buNone/>
-            </a:pPr>
-            <a:r>
-              <a:rPr lang="en-US" sz="1050" b="1" spc="200" kern="0" dirty="0">
-                <a:solidFill>
-                  <a:srgbClr val="B5392A"/>
-                </a:solidFill>
-                <a:latin typeface="JetBrains Mono" pitchFamily="34" charset="0"/>
-                <a:ea typeface="JetBrains Mono" pitchFamily="34" charset="-122"/>
-                <a:cs typeface="JetBrains Mono" pitchFamily="34" charset="-120"/>
-              </a:rPr>
-              <a:t>14</a:t>
-            </a:r>
-            <a:pPr algn="r" indent="0" marL="0">
-              <a:buNone/>
-            </a:pPr>
-            <a:r>
-              <a:rPr lang="en-US" sz="1050" spc="200" kern="0" dirty="0">
-                <a:solidFill>
-                  <a:srgbClr val="1A1714"/>
-                </a:solidFill>
-                <a:latin typeface="JetBrains Mono" pitchFamily="34" charset="0"/>
-                <a:ea typeface="JetBrains Mono" pitchFamily="34" charset="-122"/>
-                <a:cs typeface="JetBrains Mono" pitchFamily="34" charset="-120"/>
-              </a:rPr>
-              <a:t> / 15</a:t>
-            </a:r>
-            <a:endParaRPr lang="en-US" sz="1050" dirty="0"/>
-          </a:p>
-        </p:txBody>
-      </p:sp>
-      <p:pic>
-        <p:nvPicPr>
-          <p:cNvPr id="20" name="Picture 19" descr="paceline.png"/>
-          <p:cNvPicPr>
-            <a:picLocks noChangeAspect="1"/>
-          </p:cNvPicPr>
-          <p:nvPr/>
-        </p:nvPicPr>
-        <p:blipFill>
-          <a:blip r:embed="rId3"/>
-          <a:stretch>
-            <a:fillRect/>
-          </a:stretch>
-        </p:blipFill>
-        <p:spPr>
-          <a:xfrm>
-            <a:off x="1203807" y="4160520"/>
-            <a:ext cx="9784080" cy="1738493"/>
-          </a:xfrm>
-          <a:prstGeom prst="rect">
-            <a:avLst/>
-          </a:prstGeom>
-        </p:spPr>
-      </p:pic>
-      <p:sp>
-        <p:nvSpPr>
-          <p:cNvPr id="21" name="TextBox 20"/>
-          <p:cNvSpPr txBox="1"/>
-          <p:nvPr/>
-        </p:nvSpPr>
-        <p:spPr>
-          <a:xfrm>
-            <a:off x="1203807" y="5944733"/>
-            <a:ext cx="9784080" cy="320040"/>
-          </a:xfrm>
-          <a:prstGeom prst="rect">
-            <a:avLst/>
-          </a:prstGeom>
-          <a:noFill/>
-        </p:spPr>
-        <p:txBody>
-          <a:bodyPr wrap="square">
-            <a:noAutofit/>
-          </a:bodyPr>
-          <a:lstStyle/>
-          <a:p>
-            <a:r>
-              <a:rPr sz="1050">
-                <a:solidFill>
-                  <a:srgbClr val="6B6258"/>
-                </a:solidFill>
-                <a:latin typeface="Inter"/>
-              </a:rPr>
-              <a:t>What this shows: riders draft behind the leader and rotate the front; the team's clock is the 4th rider.</a:t>
-            </a:r>
           </a:p>
         </p:txBody>
       </p:sp>
@@ -5715,7 +5044,7 @@
                 <a:ea typeface="JetBrains Mono" pitchFamily="34" charset="-122"/>
                 <a:cs typeface="JetBrains Mono" pitchFamily="34" charset="-120"/>
               </a:rPr>
-              <a:t>15</a:t>
+              <a:t>14</a:t>
             </a:r>
             <a:endParaRPr lang="en-US" sz="1300" dirty="0"/>
           </a:p>
@@ -6191,7 +5520,7 @@
                 <a:ea typeface="JetBrains Mono" pitchFamily="34" charset="-122"/>
                 <a:cs typeface="JetBrains Mono" pitchFamily="34" charset="-120"/>
               </a:rPr>
-              <a:t>15</a:t>
+              <a:t>14</a:t>
             </a:r>
             <a:pPr algn="r" indent="0" marL="0">
               <a:buNone/>
@@ -6205,7 +5534,7 @@
                 <a:ea typeface="JetBrains Mono" pitchFamily="34" charset="-122"/>
                 <a:cs typeface="JetBrains Mono" pitchFamily="34" charset="-120"/>
               </a:rPr>
-              <a:t> / 15</a:t>
+              <a:t> / 14</a:t>
             </a:r>
             <a:endParaRPr lang="en-US" sz="1050" dirty="0"/>
           </a:p>
@@ -7457,7 +6786,7 @@
                 <a:ea typeface="JetBrains Mono" pitchFamily="34" charset="-122"/>
                 <a:cs typeface="JetBrains Mono" pitchFamily="34" charset="-120"/>
               </a:rPr>
-              <a:t> / 15</a:t>
+              <a:t> / 14</a:t>
             </a:r>
             <a:endParaRPr lang="en-US" sz="1050" dirty="0"/>
           </a:p>
@@ -7790,7 +7119,7 @@
                 <a:ea typeface="JetBrains Mono" pitchFamily="34" charset="-122"/>
                 <a:cs typeface="JetBrains Mono" pitchFamily="34" charset="-120"/>
               </a:rPr>
-              <a:t> / 15</a:t>
+              <a:t> / 14</a:t>
             </a:r>
             <a:endParaRPr lang="en-US" sz="1050" dirty="0"/>
           </a:p>
@@ -8342,7 +7671,7 @@
                 <a:ea typeface="JetBrains Mono" pitchFamily="34" charset="-122"/>
                 <a:cs typeface="JetBrains Mono" pitchFamily="34" charset="-120"/>
               </a:rPr>
-              <a:t> / 15</a:t>
+              <a:t> / 14</a:t>
             </a:r>
             <a:endParaRPr lang="en-US" sz="1050" dirty="0"/>
           </a:p>
@@ -8785,7 +8114,7 @@
                 <a:ea typeface="JetBrains Mono" pitchFamily="34" charset="-122"/>
                 <a:cs typeface="JetBrains Mono" pitchFamily="34" charset="-120"/>
               </a:rPr>
-              <a:t> / 15</a:t>
+              <a:t> / 14</a:t>
             </a:r>
             <a:endParaRPr lang="en-US" sz="1050" dirty="0"/>
           </a:p>
@@ -9987,7 +9316,7 @@
                 <a:ea typeface="JetBrains Mono" pitchFamily="34" charset="-122"/>
                 <a:cs typeface="JetBrains Mono" pitchFamily="34" charset="-120"/>
               </a:rPr>
-              <a:t> / 15</a:t>
+              <a:t> / 14</a:t>
             </a:r>
             <a:endParaRPr lang="en-US" sz="1050" dirty="0"/>
           </a:p>
@@ -10581,7 +9910,7 @@
                 <a:ea typeface="JetBrains Mono" pitchFamily="34" charset="-122"/>
                 <a:cs typeface="JetBrains Mono" pitchFamily="34" charset="-120"/>
               </a:rPr>
-              <a:t> / 15</a:t>
+              <a:t> / 14</a:t>
             </a:r>
             <a:endParaRPr lang="en-US" sz="1050" dirty="0"/>
           </a:p>
@@ -11080,7 +10409,7 @@
                 <a:ea typeface="JetBrains Mono" pitchFamily="34" charset="-122"/>
                 <a:cs typeface="JetBrains Mono" pitchFamily="34" charset="-120"/>
               </a:rPr>
-              <a:t> / 15</a:t>
+              <a:t> / 14</a:t>
             </a:r>
             <a:endParaRPr lang="en-US" sz="1050" dirty="0"/>
           </a:p>
@@ -11574,7 +10903,7 @@
                 <a:ea typeface="JetBrains Mono" pitchFamily="34" charset="-122"/>
                 <a:cs typeface="JetBrains Mono" pitchFamily="34" charset="-120"/>
               </a:rPr>
-              <a:t> / 15</a:t>
+              <a:t> / 14</a:t>
             </a:r>
             <a:endParaRPr lang="en-US" sz="1050" dirty="0"/>
           </a:p>

</xml_diff>